<commit_message>
fix: repair PPTX XML structure and add standalone HTML presentation
</commit_message>
<xml_diff>
--- a/StockLink_Capstone_Presentation.pptx
+++ b/StockLink_Capstone_Presentation.pptx
@@ -3085,6 +3085,14 @@
 <file path=ppt/slides/slide1.xml><?xml version="1.0" encoding="utf-8"?>
 <p:sld xmlns:a="http://schemas.openxmlformats.org/drawingml/2006/main" xmlns:p="http://schemas.openxmlformats.org/presentationml/2006/main" xmlns:r="http://schemas.openxmlformats.org/officeDocument/2006/relationships">
   <p:cSld>
+    <p:bg>
+      <p:bgPr>
+        <a:solidFill>
+          <a:srgbClr val="1A1622"/>
+        </a:solidFill>
+        <a:effectLst/>
+      </p:bgPr>
+    </p:bg>
     <p:spTree>
       <p:nvGrpSpPr>
         <p:cNvPr id="1" name=""/>
@@ -3100,17 +3108,19 @@
         </p:nvSpPr>
         <p:spPr>
           <a:xfrm>
-            <a:off x="0" y="0"/>
-            <a:ext cx="12191695" cy="6858000"/>
+            <a:off x="731520" y="731520"/>
+            <a:ext cx="1371600" cy="73152"/>
           </a:xfrm>
           <a:prstGeom prst="rect">
             <a:avLst/>
           </a:prstGeom>
           <a:solidFill>
-            <a:srgbClr val="1A1622"/>
+            <a:srgbClr val="FFA062"/>
           </a:solidFill>
-          <a:ln>
-            <a:noFill/>
+          <a:ln w="12700">
+            <a:solidFill>
+              <a:srgbClr val="FFA062"/>
+            </a:solidFill>
           </a:ln>
         </p:spPr>
         <p:style>
@@ -3137,56 +3147,13 @@
       </p:sp>
       <p:sp>
         <p:nvSpPr>
-          <p:cNvPr id="3" name="Rectangle 2"/>
-          <p:cNvSpPr/>
+          <p:cNvPr id="3" name="TextBox 2"/>
+          <p:cNvSpPr txBox="1"/>
           <p:nvPr/>
         </p:nvSpPr>
         <p:spPr>
           <a:xfrm>
-            <a:off x="731520" y="731520"/>
-            <a:ext cx="1097280" cy="73152"/>
-          </a:xfrm>
-          <a:prstGeom prst="rect">
-            <a:avLst/>
-          </a:prstGeom>
-          <a:solidFill>
-            <a:srgbClr val="FFA062"/>
-          </a:solidFill>
-          <a:ln>
-            <a:noFill/>
-          </a:ln>
-        </p:spPr>
-        <p:style>
-          <a:lnRef idx="1">
-            <a:schemeClr val="accent1"/>
-          </a:lnRef>
-          <a:fillRef idx="3">
-            <a:schemeClr val="accent1"/>
-          </a:fillRef>
-          <a:effectRef idx="2">
-            <a:schemeClr val="accent1"/>
-          </a:effectRef>
-          <a:fontRef idx="minor">
-            <a:schemeClr val="lt1"/>
-          </a:fontRef>
-        </p:style>
-        <p:txBody>
-          <a:bodyPr rtlCol="0" anchor="ctr"/>
-          <a:lstStyle/>
-          <a:p>
-            <a:pPr algn="ctr"/>
-          </a:p>
-        </p:txBody>
-      </p:sp>
-      <p:sp>
-        <p:nvSpPr>
-          <p:cNvPr id="4" name="TextBox 3"/>
-          <p:cNvSpPr txBox="1"/>
-          <p:nvPr/>
-        </p:nvSpPr>
-        <p:spPr>
-          <a:xfrm>
-            <a:off x="731520" y="1005840"/>
+            <a:off x="731520" y="960120"/>
             <a:ext cx="10698480" cy="1280160"/>
           </a:xfrm>
           <a:prstGeom prst="rect">
@@ -3205,6 +3172,7 @@
                 <a:solidFill>
                   <a:srgbClr val="FFFFFF"/>
                 </a:solidFill>
+                <a:latin typeface="Arial"/>
               </a:defRPr>
             </a:pPr>
             <a:r>
@@ -3214,12 +3182,13 @@
           <a:p>
             <a:pPr>
               <a:spcBef>
-                <a:spcPts val="800"/>
+                <a:spcPts val="600"/>
               </a:spcBef>
               <a:defRPr sz="1800" b="1">
                 <a:solidFill>
                   <a:srgbClr val="FFA062"/>
                 </a:solidFill>
+                <a:latin typeface="Arial"/>
               </a:defRPr>
             </a:pPr>
             <a:r>
@@ -3230,14 +3199,14 @@
       </p:sp>
       <p:sp>
         <p:nvSpPr>
-          <p:cNvPr id="5" name="Rounded Rectangle 4"/>
+          <p:cNvPr id="4" name="Rounded Rectangle 3"/>
           <p:cNvSpPr/>
           <p:nvPr/>
         </p:nvSpPr>
         <p:spPr>
           <a:xfrm>
             <a:off x="731520" y="2468880"/>
-            <a:ext cx="5120640" cy="3840480"/>
+            <a:ext cx="5120640" cy="3931920"/>
           </a:xfrm>
           <a:prstGeom prst="roundRect">
             <a:avLst/>
@@ -3245,7 +3214,7 @@
           <a:solidFill>
             <a:srgbClr val="262030"/>
           </a:solidFill>
-          <a:ln>
+          <a:ln w="19050">
             <a:solidFill>
               <a:srgbClr val="413750"/>
             </a:solidFill>
@@ -3275,14 +3244,14 @@
       </p:sp>
       <p:sp>
         <p:nvSpPr>
-          <p:cNvPr id="6" name="TextBox 5"/>
+          <p:cNvPr id="5" name="TextBox 4"/>
           <p:cNvSpPr txBox="1"/>
           <p:nvPr/>
         </p:nvSpPr>
         <p:spPr>
           <a:xfrm>
-            <a:off x="1005840" y="2651760"/>
-            <a:ext cx="4572000" cy="3474720"/>
+            <a:off x="960120" y="2651760"/>
+            <a:ext cx="4663440" cy="3566160"/>
           </a:xfrm>
           <a:prstGeom prst="rect">
             <a:avLst/>
@@ -3297,138 +3266,147 @@
           <a:p>
             <a:pPr>
               <a:spcAft>
-                <a:spcPts val="1400"/>
+                <a:spcPts val="1200"/>
               </a:spcAft>
               <a:defRPr sz="1300" b="1">
                 <a:solidFill>
                   <a:srgbClr val="FFA062"/>
                 </a:solidFill>
-              </a:defRPr>
-            </a:pPr>
-            <a:r>
-              <a:t>PROJECT TEAM (4 MEMBERS)</a:t>
-            </a:r>
-          </a:p>
-          <a:p>
-            <a:pPr>
-              <a:defRPr sz="1400" b="1">
+                <a:latin typeface="Arial"/>
+              </a:defRPr>
+            </a:pPr>
+            <a:r>
+              <a:t>PROJECT TEAM &amp; ROLE ALLOCATION</a:t>
+            </a:r>
+          </a:p>
+          <a:p>
+            <a:pPr>
+              <a:defRPr sz="1300" b="1">
                 <a:solidFill>
                   <a:srgbClr val="FFFFFF"/>
                 </a:solidFill>
-              </a:defRPr>
-            </a:pPr>
-            <a:r>
-              <a:t>•  Praween Singh Rawat</a:t>
-            </a:r>
-          </a:p>
-          <a:p>
-            <a:pPr>
-              <a:spcAft>
-                <a:spcPts val="800"/>
-              </a:spcAft>
-              <a:defRPr sz="1100">
+                <a:latin typeface="Arial"/>
+              </a:defRPr>
+            </a:pPr>
+            <a:r>
+              <a:t>•  Praween Singh Rawat  (Frontend Lead)</a:t>
+            </a:r>
+          </a:p>
+          <a:p>
+            <a:pPr>
+              <a:spcAft>
+                <a:spcPts val="600"/>
+              </a:spcAft>
+              <a:defRPr sz="1050">
                 <a:solidFill>
                   <a:srgbClr val="B9AFC6"/>
                 </a:solidFill>
-              </a:defRPr>
-            </a:pPr>
-            <a:r>
-              <a:t>    Frontend Lead · UI/UX &amp; Dashboard Architecture</a:t>
-            </a:r>
-          </a:p>
-          <a:p>
-            <a:pPr>
-              <a:defRPr sz="1400" b="1">
+                <a:latin typeface="Arial"/>
+              </a:defRPr>
+            </a:pPr>
+            <a:r>
+              <a:t>    UI/UX, Dashboards &amp; Profile Modules</a:t>
+            </a:r>
+          </a:p>
+          <a:p>
+            <a:pPr>
+              <a:defRPr sz="1300" b="1">
                 <a:solidFill>
                   <a:srgbClr val="FFFFFF"/>
                 </a:solidFill>
-              </a:defRPr>
-            </a:pPr>
-            <a:r>
-              <a:t>•  Anvitha S</a:t>
-            </a:r>
-          </a:p>
-          <a:p>
-            <a:pPr>
-              <a:spcAft>
-                <a:spcPts val="800"/>
-              </a:spcAft>
-              <a:defRPr sz="1100">
+                <a:latin typeface="Arial"/>
+              </a:defRPr>
+            </a:pPr>
+            <a:r>
+              <a:t>•  Anvitha S  (Frontend Developer)</a:t>
+            </a:r>
+          </a:p>
+          <a:p>
+            <a:pPr>
+              <a:spcAft>
+                <a:spcPts val="600"/>
+              </a:spcAft>
+              <a:defRPr sz="1050">
                 <a:solidFill>
                   <a:srgbClr val="B9AFC6"/>
                 </a:solidFill>
-              </a:defRPr>
-            </a:pPr>
-            <a:r>
-              <a:t>    Frontend Developer · Auth, Onboarding &amp; State Logic</a:t>
-            </a:r>
-          </a:p>
-          <a:p>
-            <a:pPr>
-              <a:defRPr sz="1400" b="1">
+                <a:latin typeface="Arial"/>
+              </a:defRPr>
+            </a:pPr>
+            <a:r>
+              <a:t>    Auth, Onboarding Wizards &amp; State Logic</a:t>
+            </a:r>
+          </a:p>
+          <a:p>
+            <a:pPr>
+              <a:defRPr sz="1300" b="1">
                 <a:solidFill>
                   <a:srgbClr val="FFFFFF"/>
                 </a:solidFill>
-              </a:defRPr>
-            </a:pPr>
-            <a:r>
-              <a:t>•  Tanishq Mittal</a:t>
-            </a:r>
-          </a:p>
-          <a:p>
-            <a:pPr>
-              <a:spcAft>
-                <a:spcPts val="800"/>
-              </a:spcAft>
-              <a:defRPr sz="1100">
+                <a:latin typeface="Arial"/>
+              </a:defRPr>
+            </a:pPr>
+            <a:r>
+              <a:t>•  Tanishq Mittal  (Backend Lead)</a:t>
+            </a:r>
+          </a:p>
+          <a:p>
+            <a:pPr>
+              <a:spcAft>
+                <a:spcPts val="600"/>
+              </a:spcAft>
+              <a:defRPr sz="1050">
                 <a:solidFill>
                   <a:srgbClr val="B9AFC6"/>
                 </a:solidFill>
-              </a:defRPr>
-            </a:pPr>
-            <a:r>
-              <a:t>    Backend Lead · REST APIs, RBAC &amp; Data Models</a:t>
-            </a:r>
-          </a:p>
-          <a:p>
-            <a:pPr>
-              <a:defRPr sz="1400" b="1">
+                <a:latin typeface="Arial"/>
+              </a:defRPr>
+            </a:pPr>
+            <a:r>
+              <a:t>    REST APIs, RBAC Middleware &amp; Data Models</a:t>
+            </a:r>
+          </a:p>
+          <a:p>
+            <a:pPr>
+              <a:defRPr sz="1300" b="1">
                 <a:solidFill>
                   <a:srgbClr val="FFFFFF"/>
                 </a:solidFill>
-              </a:defRPr>
-            </a:pPr>
-            <a:r>
-              <a:t>•  Ashraj Singh Rana</a:t>
-            </a:r>
-          </a:p>
-          <a:p>
-            <a:pPr>
-              <a:spcAft>
-                <a:spcPts val="800"/>
-              </a:spcAft>
-              <a:defRPr sz="1100">
+                <a:latin typeface="Arial"/>
+              </a:defRPr>
+            </a:pPr>
+            <a:r>
+              <a:t>•  Ashraj Singh Rana  (Backend &amp; DevOps)</a:t>
+            </a:r>
+          </a:p>
+          <a:p>
+            <a:pPr>
+              <a:spcAft>
+                <a:spcPts val="600"/>
+              </a:spcAft>
+              <a:defRPr sz="1050">
                 <a:solidFill>
                   <a:srgbClr val="B9AFC6"/>
                 </a:solidFill>
-              </a:defRPr>
-            </a:pPr>
-            <a:r>
-              <a:t>    Backend &amp; DevOps · Aggregations &amp; Cloud Deployment</a:t>
-            </a:r>
-          </a:p>
-        </p:txBody>
-      </p:sp>
-      <p:sp>
-        <p:nvSpPr>
-          <p:cNvPr id="7" name="Rounded Rectangle 6"/>
+                <a:latin typeface="Arial"/>
+              </a:defRPr>
+            </a:pPr>
+            <a:r>
+              <a:t>    Live Aggregation Engines &amp; Cloud Deployments</a:t>
+            </a:r>
+          </a:p>
+        </p:txBody>
+      </p:sp>
+      <p:sp>
+        <p:nvSpPr>
+          <p:cNvPr id="6" name="Rounded Rectangle 5"/>
           <p:cNvSpPr/>
           <p:nvPr/>
         </p:nvSpPr>
         <p:spPr>
           <a:xfrm>
             <a:off x="6217920" y="2468880"/>
-            <a:ext cx="5212080" cy="3840480"/>
+            <a:ext cx="5212080" cy="3931920"/>
           </a:xfrm>
           <a:prstGeom prst="roundRect">
             <a:avLst/>
@@ -3436,7 +3414,7 @@
           <a:solidFill>
             <a:srgbClr val="262030"/>
           </a:solidFill>
-          <a:ln>
+          <a:ln w="19050">
             <a:solidFill>
               <a:srgbClr val="413750"/>
             </a:solidFill>
@@ -3466,14 +3444,14 @@
       </p:sp>
       <p:sp>
         <p:nvSpPr>
-          <p:cNvPr id="8" name="TextBox 7"/>
+          <p:cNvPr id="7" name="TextBox 6"/>
           <p:cNvSpPr txBox="1"/>
           <p:nvPr/>
         </p:nvSpPr>
         <p:spPr>
           <a:xfrm>
-            <a:off x="6492240" y="2651760"/>
-            <a:ext cx="4663440" cy="3474720"/>
+            <a:off x="6446520" y="2651760"/>
+            <a:ext cx="4754880" cy="3566160"/>
           </a:xfrm>
           <a:prstGeom prst="rect">
             <a:avLst/>
@@ -3488,12 +3466,13 @@
           <a:p>
             <a:pPr>
               <a:spcAft>
-                <a:spcPts val="1400"/>
+                <a:spcPts val="1200"/>
               </a:spcAft>
               <a:defRPr sz="1300" b="1">
                 <a:solidFill>
                   <a:srgbClr val="FFA062"/>
                 </a:solidFill>
+                <a:latin typeface="Arial"/>
               </a:defRPr>
             </a:pPr>
             <a:r>
@@ -3502,77 +3481,147 @@
           </a:p>
           <a:p>
             <a:pPr>
-              <a:spcAft>
-                <a:spcPts val="1000"/>
-              </a:spcAft>
-              <a:defRPr sz="1300" b="1">
-                <a:solidFill>
-                  <a:srgbClr val="D7D0E1"/>
-                </a:solidFill>
-              </a:defRPr>
-            </a:pPr>
-            <a:r>
-              <a:t>[01]  Project Overview &amp; Problem Statement  (2 Mins)</a:t>
-            </a:r>
-          </a:p>
-          <a:p>
-            <a:pPr>
-              <a:spcAft>
-                <a:spcPts val="1000"/>
-              </a:spcAft>
-              <a:defRPr sz="1300" b="1">
-                <a:solidFill>
-                  <a:srgbClr val="D7D0E1"/>
-                </a:solidFill>
-              </a:defRPr>
-            </a:pPr>
-            <a:r>
-              <a:t>[02]  Technologies Used &amp; Team Member Roles  (2 Mins)</a:t>
-            </a:r>
-          </a:p>
-          <a:p>
-            <a:pPr>
-              <a:spcAft>
-                <a:spcPts val="1000"/>
-              </a:spcAft>
-              <a:defRPr sz="1300" b="1">
-                <a:solidFill>
-                  <a:srgbClr val="D7D0E1"/>
-                </a:solidFill>
-              </a:defRPr>
-            </a:pPr>
-            <a:r>
-              <a:t>[03]  System Workflows, Architecture &amp; Features  (2 Mins)</a:t>
-            </a:r>
-          </a:p>
-          <a:p>
-            <a:pPr>
-              <a:spcAft>
-                <a:spcPts val="1000"/>
-              </a:spcAft>
-              <a:defRPr sz="1300" b="1">
-                <a:solidFill>
-                  <a:srgbClr val="D7D0E1"/>
-                </a:solidFill>
-              </a:defRPr>
-            </a:pPr>
-            <a:r>
-              <a:t>[04]  Advantages, Disadvantages &amp; Future Roadmap  (2 Mins)</a:t>
-            </a:r>
-          </a:p>
-          <a:p>
-            <a:pPr>
-              <a:spcAft>
-                <a:spcPts val="1000"/>
-              </a:spcAft>
-              <a:defRPr sz="1300" b="1">
-                <a:solidFill>
-                  <a:srgbClr val="D7D0E1"/>
-                </a:solidFill>
-              </a:defRPr>
-            </a:pPr>
-            <a:r>
-              <a:t>[05]  Live Project Hosting &amp; Key Learning Takeaways  (2 Mins)</a:t>
+              <a:defRPr sz="1250" b="1">
+                <a:solidFill>
+                  <a:srgbClr val="E1DAEB"/>
+                </a:solidFill>
+                <a:latin typeface="Arial"/>
+              </a:defRPr>
+            </a:pPr>
+            <a:r>
+              <a:t>[01]  Project Title, Domain &amp; Problem Statement</a:t>
+            </a:r>
+          </a:p>
+          <a:p>
+            <a:pPr>
+              <a:spcAft>
+                <a:spcPts val="600"/>
+              </a:spcAft>
+              <a:defRPr sz="1000">
+                <a:solidFill>
+                  <a:srgbClr val="B9AFC6"/>
+                </a:solidFill>
+                <a:latin typeface="Arial"/>
+              </a:defRPr>
+            </a:pPr>
+            <a:r>
+              <a:t>       2 Mins · Praween</a:t>
+            </a:r>
+          </a:p>
+          <a:p>
+            <a:pPr>
+              <a:defRPr sz="1250" b="1">
+                <a:solidFill>
+                  <a:srgbClr val="E1DAEB"/>
+                </a:solidFill>
+                <a:latin typeface="Arial"/>
+              </a:defRPr>
+            </a:pPr>
+            <a:r>
+              <a:t>[02]  Technologies Used &amp; Team Member Roles</a:t>
+            </a:r>
+          </a:p>
+          <a:p>
+            <a:pPr>
+              <a:spcAft>
+                <a:spcPts val="600"/>
+              </a:spcAft>
+              <a:defRPr sz="1000">
+                <a:solidFill>
+                  <a:srgbClr val="B9AFC6"/>
+                </a:solidFill>
+                <a:latin typeface="Arial"/>
+              </a:defRPr>
+            </a:pPr>
+            <a:r>
+              <a:t>       2 Mins · Anvitha &amp; Tanishq</a:t>
+            </a:r>
+          </a:p>
+          <a:p>
+            <a:pPr>
+              <a:defRPr sz="1250" b="1">
+                <a:solidFill>
+                  <a:srgbClr val="E1DAEB"/>
+                </a:solidFill>
+                <a:latin typeface="Arial"/>
+              </a:defRPr>
+            </a:pPr>
+            <a:r>
+              <a:t>[03]  System Architecture &amp; Live Workflows</a:t>
+            </a:r>
+          </a:p>
+          <a:p>
+            <a:pPr>
+              <a:spcAft>
+                <a:spcPts val="600"/>
+              </a:spcAft>
+              <a:defRPr sz="1000">
+                <a:solidFill>
+                  <a:srgbClr val="B9AFC6"/>
+                </a:solidFill>
+                <a:latin typeface="Arial"/>
+              </a:defRPr>
+            </a:pPr>
+            <a:r>
+              <a:t>       2 Mins · Praween &amp; Ashraj</a:t>
+            </a:r>
+          </a:p>
+          <a:p>
+            <a:pPr>
+              <a:defRPr sz="1250" b="1">
+                <a:solidFill>
+                  <a:srgbClr val="E1DAEB"/>
+                </a:solidFill>
+                <a:latin typeface="Arial"/>
+              </a:defRPr>
+            </a:pPr>
+            <a:r>
+              <a:t>[04]  Advantages, Disadvantages &amp; Roadmap</a:t>
+            </a:r>
+          </a:p>
+          <a:p>
+            <a:pPr>
+              <a:spcAft>
+                <a:spcPts val="600"/>
+              </a:spcAft>
+              <a:defRPr sz="1000">
+                <a:solidFill>
+                  <a:srgbClr val="B9AFC6"/>
+                </a:solidFill>
+                <a:latin typeface="Arial"/>
+              </a:defRPr>
+            </a:pPr>
+            <a:r>
+              <a:t>       2 Mins · Tanishq &amp; Anvitha</a:t>
+            </a:r>
+          </a:p>
+          <a:p>
+            <a:pPr>
+              <a:defRPr sz="1250" b="1">
+                <a:solidFill>
+                  <a:srgbClr val="E1DAEB"/>
+                </a:solidFill>
+                <a:latin typeface="Arial"/>
+              </a:defRPr>
+            </a:pPr>
+            <a:r>
+              <a:t>[05]  Live Cloud Hosting &amp; Key Learning Takeaways</a:t>
+            </a:r>
+          </a:p>
+          <a:p>
+            <a:pPr>
+              <a:spcAft>
+                <a:spcPts val="600"/>
+              </a:spcAft>
+              <a:defRPr sz="1000">
+                <a:solidFill>
+                  <a:srgbClr val="B9AFC6"/>
+                </a:solidFill>
+                <a:latin typeface="Arial"/>
+              </a:defRPr>
+            </a:pPr>
+            <a:r>
+              <a:t>       2 Mins · Ashraj &amp; Praween</a:t>
             </a:r>
           </a:p>
         </p:txBody>
@@ -3588,6 +3637,14 @@
 <file path=ppt/slides/slide2.xml><?xml version="1.0" encoding="utf-8"?>
 <p:sld xmlns:a="http://schemas.openxmlformats.org/drawingml/2006/main" xmlns:p="http://schemas.openxmlformats.org/presentationml/2006/main" xmlns:r="http://schemas.openxmlformats.org/officeDocument/2006/relationships">
   <p:cSld>
+    <p:bg>
+      <p:bgPr>
+        <a:solidFill>
+          <a:srgbClr val="1A1622"/>
+        </a:solidFill>
+        <a:effectLst/>
+      </p:bgPr>
+    </p:bg>
     <p:spTree>
       <p:nvGrpSpPr>
         <p:cNvPr id="1" name=""/>
@@ -3597,57 +3654,14 @@
       <p:grpSpPr/>
       <p:sp>
         <p:nvSpPr>
-          <p:cNvPr id="2" name="Rectangle 1"/>
-          <p:cNvSpPr/>
-          <p:nvPr/>
-        </p:nvSpPr>
-        <p:spPr>
-          <a:xfrm>
-            <a:off x="0" y="0"/>
-            <a:ext cx="12191695" cy="6858000"/>
-          </a:xfrm>
-          <a:prstGeom prst="rect">
-            <a:avLst/>
-          </a:prstGeom>
-          <a:solidFill>
-            <a:srgbClr val="1A1622"/>
-          </a:solidFill>
-          <a:ln>
-            <a:noFill/>
-          </a:ln>
-        </p:spPr>
-        <p:style>
-          <a:lnRef idx="1">
-            <a:schemeClr val="accent1"/>
-          </a:lnRef>
-          <a:fillRef idx="3">
-            <a:schemeClr val="accent1"/>
-          </a:fillRef>
-          <a:effectRef idx="2">
-            <a:schemeClr val="accent1"/>
-          </a:effectRef>
-          <a:fontRef idx="minor">
-            <a:schemeClr val="lt1"/>
-          </a:fontRef>
-        </p:style>
-        <p:txBody>
-          <a:bodyPr rtlCol="0" anchor="ctr"/>
-          <a:lstStyle/>
-          <a:p>
-            <a:pPr algn="ctr"/>
-          </a:p>
-        </p:txBody>
-      </p:sp>
-      <p:sp>
-        <p:nvSpPr>
-          <p:cNvPr id="3" name="TextBox 2"/>
+          <p:cNvPr id="2" name="TextBox 1"/>
           <p:cNvSpPr txBox="1"/>
           <p:nvPr/>
         </p:nvSpPr>
         <p:spPr>
           <a:xfrm>
             <a:off x="731520" y="365760"/>
-            <a:ext cx="10698480" cy="365760"/>
+            <a:ext cx="10698480" cy="320040"/>
           </a:xfrm>
           <a:prstGeom prst="rect">
             <a:avLst/>
@@ -3655,7 +3669,7 @@
           <a:noFill/>
         </p:spPr>
         <p:txBody>
-          <a:bodyPr wrap="square" lIns="0" tIns="0" rIns="0" bIns="0">
+          <a:bodyPr wrap="square">
             <a:spAutoFit/>
           </a:bodyPr>
           <a:lstStyle/>
@@ -3665,6 +3679,7 @@
                 <a:solidFill>
                   <a:srgbClr val="FFA062"/>
                 </a:solidFill>
+                <a:latin typeface="Arial"/>
               </a:defRPr>
             </a:pPr>
             <a:r>
@@ -3675,14 +3690,14 @@
       </p:sp>
       <p:sp>
         <p:nvSpPr>
-          <p:cNvPr id="4" name="TextBox 3"/>
+          <p:cNvPr id="3" name="TextBox 2"/>
           <p:cNvSpPr txBox="1"/>
           <p:nvPr/>
         </p:nvSpPr>
         <p:spPr>
           <a:xfrm>
             <a:off x="731520" y="685800"/>
-            <a:ext cx="10698480" cy="640080"/>
+            <a:ext cx="10698480" cy="594360"/>
           </a:xfrm>
           <a:prstGeom prst="rect">
             <a:avLst/>
@@ -3690,7 +3705,7 @@
           <a:noFill/>
         </p:spPr>
         <p:txBody>
-          <a:bodyPr wrap="square" lIns="0" tIns="0" rIns="0" bIns="0">
+          <a:bodyPr wrap="square">
             <a:spAutoFit/>
           </a:bodyPr>
           <a:lstStyle/>
@@ -3700,6 +3715,7 @@
                 <a:solidFill>
                   <a:srgbClr val="FFFFFF"/>
                 </a:solidFill>
+                <a:latin typeface="Arial"/>
               </a:defRPr>
             </a:pPr>
             <a:r>
@@ -3710,14 +3726,14 @@
       </p:sp>
       <p:sp>
         <p:nvSpPr>
-          <p:cNvPr id="5" name="Rounded Rectangle 4"/>
+          <p:cNvPr id="4" name="Rounded Rectangle 3"/>
           <p:cNvSpPr/>
           <p:nvPr/>
         </p:nvSpPr>
         <p:spPr>
           <a:xfrm>
-            <a:off x="731520" y="1463040"/>
-            <a:ext cx="3657600" cy="4846320"/>
+            <a:off x="731520" y="1417320"/>
+            <a:ext cx="3566160" cy="4937760"/>
           </a:xfrm>
           <a:prstGeom prst="roundRect">
             <a:avLst/>
@@ -3725,7 +3741,7 @@
           <a:solidFill>
             <a:srgbClr val="262030"/>
           </a:solidFill>
-          <a:ln>
+          <a:ln w="19050">
             <a:solidFill>
               <a:srgbClr val="413750"/>
             </a:solidFill>
@@ -3746,17 +3762,44 @@
           </a:fontRef>
         </p:style>
         <p:txBody>
-          <a:bodyPr rtlCol="0" anchor="ctr" wrap="square" lIns="274320" tIns="274320" rIns="274320" bIns="274320"/>
-          <a:lstStyle/>
-          <a:p>
-            <a:pPr algn="ctr">
+          <a:bodyPr rtlCol="0" anchor="ctr"/>
+          <a:lstStyle/>
+          <a:p>
+            <a:pPr algn="ctr"/>
+          </a:p>
+        </p:txBody>
+      </p:sp>
+      <p:sp>
+        <p:nvSpPr>
+          <p:cNvPr id="5" name="TextBox 4"/>
+          <p:cNvSpPr txBox="1"/>
+          <p:nvPr/>
+        </p:nvSpPr>
+        <p:spPr>
+          <a:xfrm>
+            <a:off x="914400" y="1554480"/>
+            <a:ext cx="3200400" cy="4663440"/>
+          </a:xfrm>
+          <a:prstGeom prst="rect">
+            <a:avLst/>
+          </a:prstGeom>
+          <a:noFill/>
+        </p:spPr>
+        <p:txBody>
+          <a:bodyPr wrap="square">
+            <a:spAutoFit/>
+          </a:bodyPr>
+          <a:lstStyle/>
+          <a:p>
+            <a:pPr>
               <a:spcAft>
                 <a:spcPts val="1000"/>
               </a:spcAft>
-              <a:defRPr sz="1400" b="1">
+              <a:defRPr sz="1300" b="1">
                 <a:solidFill>
                   <a:srgbClr val="FFA062"/>
                 </a:solidFill>
+                <a:latin typeface="Arial"/>
               </a:defRPr>
             </a:pPr>
             <a:r>
@@ -3765,37 +3808,40 @@
           </a:p>
           <a:p>
             <a:pPr>
-              <a:defRPr sz="1200" b="1">
+              <a:defRPr sz="1150" b="1">
                 <a:solidFill>
                   <a:srgbClr val="FFFFFF"/>
                 </a:solidFill>
-              </a:defRPr>
-            </a:pPr>
-            <a:r>
-              <a:t>• Frontend Client</a:t>
-            </a:r>
-          </a:p>
-          <a:p>
-            <a:pPr>
-              <a:spcAft>
-                <a:spcPts val="800"/>
-              </a:spcAft>
-              <a:defRPr sz="1000">
+                <a:latin typeface="Arial"/>
+              </a:defRPr>
+            </a:pPr>
+            <a:r>
+              <a:t>• Frontend Stack</a:t>
+            </a:r>
+          </a:p>
+          <a:p>
+            <a:pPr>
+              <a:spcAft>
+                <a:spcPts val="700"/>
+              </a:spcAft>
+              <a:defRPr sz="950">
                 <a:solidFill>
                   <a:srgbClr val="B9AFC6"/>
                 </a:solidFill>
-              </a:defRPr>
-            </a:pPr>
-            <a:r>
-              <a:t>React 18 · Vite · React Router v7 · Tailwind Tokens · Lucide Icons</a:t>
-            </a:r>
-          </a:p>
-          <a:p>
-            <a:pPr>
-              <a:defRPr sz="1200" b="1">
+                <a:latin typeface="Arial"/>
+              </a:defRPr>
+            </a:pPr>
+            <a:r>
+              <a:t>React 18 · Vite · React Router v7 · Tailwind Design Tokens · Lucide Icons</a:t>
+            </a:r>
+          </a:p>
+          <a:p>
+            <a:pPr>
+              <a:defRPr sz="1150" b="1">
                 <a:solidFill>
                   <a:srgbClr val="FFFFFF"/>
                 </a:solidFill>
+                <a:latin typeface="Arial"/>
               </a:defRPr>
             </a:pPr>
             <a:r>
@@ -3805,78 +3851,84 @@
           <a:p>
             <a:pPr>
               <a:spcAft>
-                <a:spcPts val="800"/>
-              </a:spcAft>
-              <a:defRPr sz="1000">
+                <a:spcPts val="700"/>
+              </a:spcAft>
+              <a:defRPr sz="950">
                 <a:solidFill>
                   <a:srgbClr val="B9AFC6"/>
                 </a:solidFill>
-              </a:defRPr>
-            </a:pPr>
-            <a:r>
-              <a:t>Node.js · Express.js · REST Architecture · Centralized Middleware</a:t>
-            </a:r>
-          </a:p>
-          <a:p>
-            <a:pPr>
-              <a:defRPr sz="1200" b="1">
+                <a:latin typeface="Arial"/>
+              </a:defRPr>
+            </a:pPr>
+            <a:r>
+              <a:t>Node.js · Express.js REST Framework · Centralized Middleware Pipeline</a:t>
+            </a:r>
+          </a:p>
+          <a:p>
+            <a:pPr>
+              <a:defRPr sz="1150" b="1">
                 <a:solidFill>
                   <a:srgbClr val="FFFFFF"/>
                 </a:solidFill>
-              </a:defRPr>
-            </a:pPr>
-            <a:r>
-              <a:t>• Database &amp; Persistence</a:t>
-            </a:r>
-          </a:p>
-          <a:p>
-            <a:pPr>
-              <a:spcAft>
-                <a:spcPts val="800"/>
-              </a:spcAft>
-              <a:defRPr sz="1000">
+                <a:latin typeface="Arial"/>
+              </a:defRPr>
+            </a:pPr>
+            <a:r>
+              <a:t>• Data Persistence</a:t>
+            </a:r>
+          </a:p>
+          <a:p>
+            <a:pPr>
+              <a:spcAft>
+                <a:spcPts val="700"/>
+              </a:spcAft>
+              <a:defRPr sz="950">
                 <a:solidFill>
                   <a:srgbClr val="B9AFC6"/>
                 </a:solidFill>
-              </a:defRPr>
-            </a:pPr>
-            <a:r>
-              <a:t>MongoDB · Mongoose Models · Resilient In-Memory Dual Store</a:t>
-            </a:r>
-          </a:p>
-          <a:p>
-            <a:pPr>
-              <a:defRPr sz="1200" b="1">
+                <a:latin typeface="Arial"/>
+              </a:defRPr>
+            </a:pPr>
+            <a:r>
+              <a:t>MongoDB · Mongoose ORM · Resilient In-Memory Dual Fallback Engine</a:t>
+            </a:r>
+          </a:p>
+          <a:p>
+            <a:pPr>
+              <a:defRPr sz="1150" b="1">
                 <a:solidFill>
                   <a:srgbClr val="FFFFFF"/>
                 </a:solidFill>
-              </a:defRPr>
-            </a:pPr>
-            <a:r>
-              <a:t>• Security &amp; Validation</a:t>
-            </a:r>
-          </a:p>
-          <a:p>
-            <a:pPr>
-              <a:spcAft>
-                <a:spcPts val="800"/>
-              </a:spcAft>
-              <a:defRPr sz="1000">
+                <a:latin typeface="Arial"/>
+              </a:defRPr>
+            </a:pPr>
+            <a:r>
+              <a:t>• Security &amp; Auth</a:t>
+            </a:r>
+          </a:p>
+          <a:p>
+            <a:pPr>
+              <a:spcAft>
+                <a:spcPts val="700"/>
+              </a:spcAft>
+              <a:defRPr sz="950">
                 <a:solidFill>
                   <a:srgbClr val="B9AFC6"/>
                 </a:solidFill>
-              </a:defRPr>
-            </a:pPr>
-            <a:r>
-              <a:t>JWT Bearer Tokens · Bcryptjs · Zod Schema Validation · RBAC</a:t>
-            </a:r>
-          </a:p>
-          <a:p>
-            <a:pPr>
-              <a:defRPr sz="1200" b="1">
+                <a:latin typeface="Arial"/>
+              </a:defRPr>
+            </a:pPr>
+            <a:r>
+              <a:t>Stateless JWT Bearer Tokens · Bcryptjs · Zod Schema Validation · RBAC</a:t>
+            </a:r>
+          </a:p>
+          <a:p>
+            <a:pPr>
+              <a:defRPr sz="1150" b="1">
                 <a:solidFill>
                   <a:srgbClr val="FFFFFF"/>
                 </a:solidFill>
+                <a:latin typeface="Arial"/>
               </a:defRPr>
             </a:pPr>
             <a:r>
@@ -3886,16 +3938,17 @@
           <a:p>
             <a:pPr>
               <a:spcAft>
-                <a:spcPts val="800"/>
-              </a:spcAft>
-              <a:defRPr sz="1000">
+                <a:spcPts val="700"/>
+              </a:spcAft>
+              <a:defRPr sz="950">
                 <a:solidFill>
                   <a:srgbClr val="B9AFC6"/>
                 </a:solidFill>
-              </a:defRPr>
-            </a:pPr>
-            <a:r>
-              <a:t>Vercel (Edge SPA) · Render (Node Service) · GitHub CI/CD</a:t>
+                <a:latin typeface="Arial"/>
+              </a:defRPr>
+            </a:pPr>
+            <a:r>
+              <a:t>Vercel (Edge CDN Frontend) · Render (Cloud Web Service) · Git Monorepo</a:t>
             </a:r>
           </a:p>
         </p:txBody>
@@ -3908,8 +3961,8 @@
         </p:nvSpPr>
         <p:spPr>
           <a:xfrm>
-            <a:off x="4663440" y="1463040"/>
-            <a:ext cx="3566160" cy="2331720"/>
+            <a:off x="4572000" y="1417320"/>
+            <a:ext cx="3566160" cy="2377440"/>
           </a:xfrm>
           <a:prstGeom prst="roundRect">
             <a:avLst/>
@@ -3917,7 +3970,7 @@
           <a:solidFill>
             <a:srgbClr val="262030"/>
           </a:solidFill>
-          <a:ln>
+          <a:ln w="19050">
             <a:solidFill>
               <a:srgbClr val="413750"/>
             </a:solidFill>
@@ -3938,14 +3991,41 @@
           </a:fontRef>
         </p:style>
         <p:txBody>
-          <a:bodyPr rtlCol="0" anchor="ctr" wrap="square" lIns="228600" tIns="228600" rIns="228600" bIns="228600"/>
-          <a:lstStyle/>
-          <a:p>
-            <a:pPr algn="ctr">
+          <a:bodyPr rtlCol="0" anchor="ctr"/>
+          <a:lstStyle/>
+          <a:p>
+            <a:pPr algn="ctr"/>
+          </a:p>
+        </p:txBody>
+      </p:sp>
+      <p:sp>
+        <p:nvSpPr>
+          <p:cNvPr id="7" name="TextBox 6"/>
+          <p:cNvSpPr txBox="1"/>
+          <p:nvPr/>
+        </p:nvSpPr>
+        <p:spPr>
+          <a:xfrm>
+            <a:off x="4754880" y="1581912"/>
+            <a:ext cx="3200400" cy="2103120"/>
+          </a:xfrm>
+          <a:prstGeom prst="rect">
+            <a:avLst/>
+          </a:prstGeom>
+          <a:noFill/>
+        </p:spPr>
+        <p:txBody>
+          <a:bodyPr wrap="square">
+            <a:spAutoFit/>
+          </a:bodyPr>
+          <a:lstStyle/>
+          <a:p>
+            <a:pPr>
               <a:defRPr sz="1300" b="1">
                 <a:solidFill>
                   <a:srgbClr val="FFFFFF"/>
                 </a:solidFill>
+                <a:latin typeface="Arial"/>
               </a:defRPr>
             </a:pPr>
             <a:r>
@@ -3961,6 +4041,7 @@
                 <a:solidFill>
                   <a:srgbClr val="FFA062"/>
                 </a:solidFill>
+                <a:latin typeface="Arial"/>
               </a:defRPr>
             </a:pPr>
             <a:r>
@@ -3974,12 +4055,13 @@
               </a:spcAft>
               <a:defRPr sz="950">
                 <a:solidFill>
-                  <a:srgbClr val="D7D0E1"/>
-                </a:solidFill>
-              </a:defRPr>
-            </a:pPr>
-            <a:r>
-              <a:t>▹ UI/UX Design tokens matching Indian Mandi branding</a:t>
+                  <a:srgbClr val="E1DAEB"/>
+                </a:solidFill>
+                <a:latin typeface="Arial"/>
+              </a:defRPr>
+            </a:pPr>
+            <a:r>
+              <a:t>▹ UI/UX Design system tailored for Mandi Commerce</a:t>
             </a:r>
           </a:p>
           <a:p>
@@ -3989,12 +4071,13 @@
               </a:spcAft>
               <a:defRPr sz="950">
                 <a:solidFill>
-                  <a:srgbClr val="D7D0E1"/>
-                </a:solidFill>
-              </a:defRPr>
-            </a:pPr>
-            <a:r>
-              <a:t>▹ Retailer &amp; Wholesaler interactive dashboards &amp; metrics</a:t>
+                  <a:srgbClr val="E1DAEB"/>
+                </a:solidFill>
+                <a:latin typeface="Arial"/>
+              </a:defRPr>
+            </a:pPr>
+            <a:r>
+              <a:t>▹ Interactive Retailer &amp; Wholesaler KPI Dashboards</a:t>
             </a:r>
           </a:p>
           <a:p>
@@ -4004,12 +4087,13 @@
               </a:spcAft>
               <a:defRPr sz="950">
                 <a:solidFill>
-                  <a:srgbClr val="D7D0E1"/>
-                </a:solidFill>
-              </a:defRPr>
-            </a:pPr>
-            <a:r>
-              <a:t>▹ Retailer &amp; Wholesaler comprehensive profile managers</a:t>
+                  <a:srgbClr val="E1DAEB"/>
+                </a:solidFill>
+                <a:latin typeface="Arial"/>
+              </a:defRPr>
+            </a:pPr>
+            <a:r>
+              <a:t>▹ Multi-section Store and Wholesaler Profile engines</a:t>
             </a:r>
           </a:p>
           <a:p>
@@ -4019,26 +4103,27 @@
               </a:spcAft>
               <a:defRPr sz="950">
                 <a:solidFill>
-                  <a:srgbClr val="D7D0E1"/>
-                </a:solidFill>
-              </a:defRPr>
-            </a:pPr>
-            <a:r>
-              <a:t>▹ Vite production build optimizations &amp; responsive layouts</a:t>
-            </a:r>
-          </a:p>
-        </p:txBody>
-      </p:sp>
-      <p:sp>
-        <p:nvSpPr>
-          <p:cNvPr id="7" name="Rounded Rectangle 6"/>
+                  <a:srgbClr val="E1DAEB"/>
+                </a:solidFill>
+                <a:latin typeface="Arial"/>
+              </a:defRPr>
+            </a:pPr>
+            <a:r>
+              <a:t>▹ Vite client optimization &amp; responsive layout design</a:t>
+            </a:r>
+          </a:p>
+        </p:txBody>
+      </p:sp>
+      <p:sp>
+        <p:nvSpPr>
+          <p:cNvPr id="8" name="Rounded Rectangle 7"/>
           <p:cNvSpPr/>
           <p:nvPr/>
         </p:nvSpPr>
         <p:spPr>
           <a:xfrm>
-            <a:off x="8412480" y="1463040"/>
-            <a:ext cx="3566160" cy="2331720"/>
+            <a:off x="8321040" y="1417320"/>
+            <a:ext cx="3566160" cy="2377440"/>
           </a:xfrm>
           <a:prstGeom prst="roundRect">
             <a:avLst/>
@@ -4046,7 +4131,7 @@
           <a:solidFill>
             <a:srgbClr val="262030"/>
           </a:solidFill>
-          <a:ln>
+          <a:ln w="19050">
             <a:solidFill>
               <a:srgbClr val="413750"/>
             </a:solidFill>
@@ -4067,14 +4152,41 @@
           </a:fontRef>
         </p:style>
         <p:txBody>
-          <a:bodyPr rtlCol="0" anchor="ctr" wrap="square" lIns="228600" tIns="228600" rIns="228600" bIns="228600"/>
-          <a:lstStyle/>
-          <a:p>
-            <a:pPr algn="ctr">
+          <a:bodyPr rtlCol="0" anchor="ctr"/>
+          <a:lstStyle/>
+          <a:p>
+            <a:pPr algn="ctr"/>
+          </a:p>
+        </p:txBody>
+      </p:sp>
+      <p:sp>
+        <p:nvSpPr>
+          <p:cNvPr id="9" name="TextBox 8"/>
+          <p:cNvSpPr txBox="1"/>
+          <p:nvPr/>
+        </p:nvSpPr>
+        <p:spPr>
+          <a:xfrm>
+            <a:off x="8503920" y="1581912"/>
+            <a:ext cx="3200400" cy="2103120"/>
+          </a:xfrm>
+          <a:prstGeom prst="rect">
+            <a:avLst/>
+          </a:prstGeom>
+          <a:noFill/>
+        </p:spPr>
+        <p:txBody>
+          <a:bodyPr wrap="square">
+            <a:spAutoFit/>
+          </a:bodyPr>
+          <a:lstStyle/>
+          <a:p>
+            <a:pPr>
               <a:defRPr sz="1300" b="1">
                 <a:solidFill>
                   <a:srgbClr val="FFFFFF"/>
                 </a:solidFill>
+                <a:latin typeface="Arial"/>
               </a:defRPr>
             </a:pPr>
             <a:r>
@@ -4090,6 +4202,7 @@
                 <a:solidFill>
                   <a:srgbClr val="FFA062"/>
                 </a:solidFill>
+                <a:latin typeface="Arial"/>
               </a:defRPr>
             </a:pPr>
             <a:r>
@@ -4103,8 +4216,9 @@
               </a:spcAft>
               <a:defRPr sz="950">
                 <a:solidFill>
-                  <a:srgbClr val="D7D0E1"/>
-                </a:solidFill>
+                  <a:srgbClr val="E1DAEB"/>
+                </a:solidFill>
+                <a:latin typeface="Arial"/>
               </a:defRPr>
             </a:pPr>
             <a:r>
@@ -4118,8 +4232,9 @@
               </a:spcAft>
               <a:defRPr sz="950">
                 <a:solidFill>
-                  <a:srgbClr val="D7D0E1"/>
-                </a:solidFill>
+                  <a:srgbClr val="E1DAEB"/>
+                </a:solidFill>
+                <a:latin typeface="Arial"/>
               </a:defRPr>
             </a:pPr>
             <a:r>
@@ -4133,12 +4248,13 @@
               </a:spcAft>
               <a:defRPr sz="950">
                 <a:solidFill>
-                  <a:srgbClr val="D7D0E1"/>
-                </a:solidFill>
-              </a:defRPr>
-            </a:pPr>
-            <a:r>
-              <a:t>▹ Centralized API service (`api.js`) &amp; token attachment</a:t>
+                  <a:srgbClr val="E1DAEB"/>
+                </a:solidFill>
+                <a:latin typeface="Arial"/>
+              </a:defRPr>
+            </a:pPr>
+            <a:r>
+              <a:t>▹ Centralized API service (`api.js`) &amp; token integration</a:t>
             </a:r>
           </a:p>
           <a:p>
@@ -4148,8 +4264,9 @@
               </a:spcAft>
               <a:defRPr sz="950">
                 <a:solidFill>
-                  <a:srgbClr val="D7D0E1"/>
-                </a:solidFill>
+                  <a:srgbClr val="E1DAEB"/>
+                </a:solidFill>
+                <a:latin typeface="Arial"/>
               </a:defRPr>
             </a:pPr>
             <a:r>
@@ -4160,14 +4277,14 @@
       </p:sp>
       <p:sp>
         <p:nvSpPr>
-          <p:cNvPr id="8" name="Rounded Rectangle 7"/>
+          <p:cNvPr id="10" name="Rounded Rectangle 9"/>
           <p:cNvSpPr/>
           <p:nvPr/>
         </p:nvSpPr>
         <p:spPr>
           <a:xfrm>
-            <a:off x="4663440" y="3977639"/>
-            <a:ext cx="3566160" cy="2331720"/>
+            <a:off x="4572000" y="3977639"/>
+            <a:ext cx="3566160" cy="2377440"/>
           </a:xfrm>
           <a:prstGeom prst="roundRect">
             <a:avLst/>
@@ -4175,7 +4292,7 @@
           <a:solidFill>
             <a:srgbClr val="262030"/>
           </a:solidFill>
-          <a:ln>
+          <a:ln w="19050">
             <a:solidFill>
               <a:srgbClr val="413750"/>
             </a:solidFill>
@@ -4196,14 +4313,41 @@
           </a:fontRef>
         </p:style>
         <p:txBody>
-          <a:bodyPr rtlCol="0" anchor="ctr" wrap="square" lIns="228600" tIns="228600" rIns="228600" bIns="228600"/>
-          <a:lstStyle/>
-          <a:p>
-            <a:pPr algn="ctr">
+          <a:bodyPr rtlCol="0" anchor="ctr"/>
+          <a:lstStyle/>
+          <a:p>
+            <a:pPr algn="ctr"/>
+          </a:p>
+        </p:txBody>
+      </p:sp>
+      <p:sp>
+        <p:nvSpPr>
+          <p:cNvPr id="11" name="TextBox 10"/>
+          <p:cNvSpPr txBox="1"/>
+          <p:nvPr/>
+        </p:nvSpPr>
+        <p:spPr>
+          <a:xfrm>
+            <a:off x="4754880" y="4142231"/>
+            <a:ext cx="3200400" cy="2103120"/>
+          </a:xfrm>
+          <a:prstGeom prst="rect">
+            <a:avLst/>
+          </a:prstGeom>
+          <a:noFill/>
+        </p:spPr>
+        <p:txBody>
+          <a:bodyPr wrap="square">
+            <a:spAutoFit/>
+          </a:bodyPr>
+          <a:lstStyle/>
+          <a:p>
+            <a:pPr>
               <a:defRPr sz="1300" b="1">
                 <a:solidFill>
                   <a:srgbClr val="FFFFFF"/>
                 </a:solidFill>
+                <a:latin typeface="Arial"/>
               </a:defRPr>
             </a:pPr>
             <a:r>
@@ -4219,6 +4363,7 @@
                 <a:solidFill>
                   <a:srgbClr val="3B82F6"/>
                 </a:solidFill>
+                <a:latin typeface="Arial"/>
               </a:defRPr>
             </a:pPr>
             <a:r>
@@ -4232,8 +4377,9 @@
               </a:spcAft>
               <a:defRPr sz="950">
                 <a:solidFill>
-                  <a:srgbClr val="D7D0E1"/>
-                </a:solidFill>
+                  <a:srgbClr val="E1DAEB"/>
+                </a:solidFill>
+                <a:latin typeface="Arial"/>
               </a:defRPr>
             </a:pPr>
             <a:r>
@@ -4247,8 +4393,9 @@
               </a:spcAft>
               <a:defRPr sz="950">
                 <a:solidFill>
-                  <a:srgbClr val="D7D0E1"/>
-                </a:solidFill>
+                  <a:srgbClr val="E1DAEB"/>
+                </a:solidFill>
+                <a:latin typeface="Arial"/>
               </a:defRPr>
             </a:pPr>
             <a:r>
@@ -4262,8 +4409,9 @@
               </a:spcAft>
               <a:defRPr sz="950">
                 <a:solidFill>
-                  <a:srgbClr val="D7D0E1"/>
-                </a:solidFill>
+                  <a:srgbClr val="E1DAEB"/>
+                </a:solidFill>
+                <a:latin typeface="Arial"/>
               </a:defRPr>
             </a:pPr>
             <a:r>
@@ -4277,8 +4425,9 @@
               </a:spcAft>
               <a:defRPr sz="950">
                 <a:solidFill>
-                  <a:srgbClr val="D7D0E1"/>
-                </a:solidFill>
+                  <a:srgbClr val="E1DAEB"/>
+                </a:solidFill>
+                <a:latin typeface="Arial"/>
               </a:defRPr>
             </a:pPr>
             <a:r>
@@ -4289,14 +4438,14 @@
       </p:sp>
       <p:sp>
         <p:nvSpPr>
-          <p:cNvPr id="9" name="Rounded Rectangle 8"/>
+          <p:cNvPr id="12" name="Rounded Rectangle 11"/>
           <p:cNvSpPr/>
           <p:nvPr/>
         </p:nvSpPr>
         <p:spPr>
           <a:xfrm>
-            <a:off x="8412480" y="3977639"/>
-            <a:ext cx="3566160" cy="2331720"/>
+            <a:off x="8321040" y="3977639"/>
+            <a:ext cx="3566160" cy="2377440"/>
           </a:xfrm>
           <a:prstGeom prst="roundRect">
             <a:avLst/>
@@ -4304,7 +4453,7 @@
           <a:solidFill>
             <a:srgbClr val="262030"/>
           </a:solidFill>
-          <a:ln>
+          <a:ln w="19050">
             <a:solidFill>
               <a:srgbClr val="413750"/>
             </a:solidFill>
@@ -4325,14 +4474,41 @@
           </a:fontRef>
         </p:style>
         <p:txBody>
-          <a:bodyPr rtlCol="0" anchor="ctr" wrap="square" lIns="228600" tIns="228600" rIns="228600" bIns="228600"/>
-          <a:lstStyle/>
-          <a:p>
-            <a:pPr algn="ctr">
+          <a:bodyPr rtlCol="0" anchor="ctr"/>
+          <a:lstStyle/>
+          <a:p>
+            <a:pPr algn="ctr"/>
+          </a:p>
+        </p:txBody>
+      </p:sp>
+      <p:sp>
+        <p:nvSpPr>
+          <p:cNvPr id="13" name="TextBox 12"/>
+          <p:cNvSpPr txBox="1"/>
+          <p:nvPr/>
+        </p:nvSpPr>
+        <p:spPr>
+          <a:xfrm>
+            <a:off x="8503920" y="4142231"/>
+            <a:ext cx="3200400" cy="2103120"/>
+          </a:xfrm>
+          <a:prstGeom prst="rect">
+            <a:avLst/>
+          </a:prstGeom>
+          <a:noFill/>
+        </p:spPr>
+        <p:txBody>
+          <a:bodyPr wrap="square">
+            <a:spAutoFit/>
+          </a:bodyPr>
+          <a:lstStyle/>
+          <a:p>
+            <a:pPr>
               <a:defRPr sz="1300" b="1">
                 <a:solidFill>
                   <a:srgbClr val="FFFFFF"/>
                 </a:solidFill>
+                <a:latin typeface="Arial"/>
               </a:defRPr>
             </a:pPr>
             <a:r>
@@ -4348,6 +4524,7 @@
                 <a:solidFill>
                   <a:srgbClr val="22C55E"/>
                 </a:solidFill>
+                <a:latin typeface="Arial"/>
               </a:defRPr>
             </a:pPr>
             <a:r>
@@ -4361,8 +4538,9 @@
               </a:spcAft>
               <a:defRPr sz="950">
                 <a:solidFill>
-                  <a:srgbClr val="D7D0E1"/>
-                </a:solidFill>
+                  <a:srgbClr val="E1DAEB"/>
+                </a:solidFill>
+                <a:latin typeface="Arial"/>
               </a:defRPr>
             </a:pPr>
             <a:r>
@@ -4376,8 +4554,9 @@
               </a:spcAft>
               <a:defRPr sz="950">
                 <a:solidFill>
-                  <a:srgbClr val="D7D0E1"/>
-                </a:solidFill>
+                  <a:srgbClr val="E1DAEB"/>
+                </a:solidFill>
+                <a:latin typeface="Arial"/>
               </a:defRPr>
             </a:pPr>
             <a:r>
@@ -4391,8 +4570,9 @@
               </a:spcAft>
               <a:defRPr sz="950">
                 <a:solidFill>
-                  <a:srgbClr val="D7D0E1"/>
-                </a:solidFill>
+                  <a:srgbClr val="E1DAEB"/>
+                </a:solidFill>
+                <a:latin typeface="Arial"/>
               </a:defRPr>
             </a:pPr>
             <a:r>
@@ -4406,8 +4586,9 @@
               </a:spcAft>
               <a:defRPr sz="950">
                 <a:solidFill>
-                  <a:srgbClr val="D7D0E1"/>
-                </a:solidFill>
+                  <a:srgbClr val="E1DAEB"/>
+                </a:solidFill>
+                <a:latin typeface="Arial"/>
               </a:defRPr>
             </a:pPr>
             <a:r>
@@ -4427,6 +4608,14 @@
 <file path=ppt/slides/slide3.xml><?xml version="1.0" encoding="utf-8"?>
 <p:sld xmlns:a="http://schemas.openxmlformats.org/drawingml/2006/main" xmlns:p="http://schemas.openxmlformats.org/presentationml/2006/main" xmlns:r="http://schemas.openxmlformats.org/officeDocument/2006/relationships">
   <p:cSld>
+    <p:bg>
+      <p:bgPr>
+        <a:solidFill>
+          <a:srgbClr val="1A1622"/>
+        </a:solidFill>
+        <a:effectLst/>
+      </p:bgPr>
+    </p:bg>
     <p:spTree>
       <p:nvGrpSpPr>
         <p:cNvPr id="1" name=""/>
@@ -4436,57 +4625,14 @@
       <p:grpSpPr/>
       <p:sp>
         <p:nvSpPr>
-          <p:cNvPr id="2" name="Rectangle 1"/>
-          <p:cNvSpPr/>
-          <p:nvPr/>
-        </p:nvSpPr>
-        <p:spPr>
-          <a:xfrm>
-            <a:off x="0" y="0"/>
-            <a:ext cx="12191695" cy="6858000"/>
-          </a:xfrm>
-          <a:prstGeom prst="rect">
-            <a:avLst/>
-          </a:prstGeom>
-          <a:solidFill>
-            <a:srgbClr val="1A1622"/>
-          </a:solidFill>
-          <a:ln>
-            <a:noFill/>
-          </a:ln>
-        </p:spPr>
-        <p:style>
-          <a:lnRef idx="1">
-            <a:schemeClr val="accent1"/>
-          </a:lnRef>
-          <a:fillRef idx="3">
-            <a:schemeClr val="accent1"/>
-          </a:fillRef>
-          <a:effectRef idx="2">
-            <a:schemeClr val="accent1"/>
-          </a:effectRef>
-          <a:fontRef idx="minor">
-            <a:schemeClr val="lt1"/>
-          </a:fontRef>
-        </p:style>
-        <p:txBody>
-          <a:bodyPr rtlCol="0" anchor="ctr"/>
-          <a:lstStyle/>
-          <a:p>
-            <a:pPr algn="ctr"/>
-          </a:p>
-        </p:txBody>
-      </p:sp>
-      <p:sp>
-        <p:nvSpPr>
-          <p:cNvPr id="3" name="TextBox 2"/>
+          <p:cNvPr id="2" name="TextBox 1"/>
           <p:cNvSpPr txBox="1"/>
           <p:nvPr/>
         </p:nvSpPr>
         <p:spPr>
           <a:xfrm>
             <a:off x="731520" y="365760"/>
-            <a:ext cx="10698480" cy="365760"/>
+            <a:ext cx="10698480" cy="320040"/>
           </a:xfrm>
           <a:prstGeom prst="rect">
             <a:avLst/>
@@ -4494,7 +4640,7 @@
           <a:noFill/>
         </p:spPr>
         <p:txBody>
-          <a:bodyPr wrap="square" lIns="0" tIns="0" rIns="0" bIns="0">
+          <a:bodyPr wrap="square">
             <a:spAutoFit/>
           </a:bodyPr>
           <a:lstStyle/>
@@ -4504,6 +4650,7 @@
                 <a:solidFill>
                   <a:srgbClr val="FFA062"/>
                 </a:solidFill>
+                <a:latin typeface="Arial"/>
               </a:defRPr>
             </a:pPr>
             <a:r>
@@ -4514,14 +4661,14 @@
       </p:sp>
       <p:sp>
         <p:nvSpPr>
-          <p:cNvPr id="4" name="TextBox 3"/>
+          <p:cNvPr id="3" name="TextBox 2"/>
           <p:cNvSpPr txBox="1"/>
           <p:nvPr/>
         </p:nvSpPr>
         <p:spPr>
           <a:xfrm>
             <a:off x="731520" y="685800"/>
-            <a:ext cx="10698480" cy="640080"/>
+            <a:ext cx="10698480" cy="594360"/>
           </a:xfrm>
           <a:prstGeom prst="rect">
             <a:avLst/>
@@ -4529,7 +4676,7 @@
           <a:noFill/>
         </p:spPr>
         <p:txBody>
-          <a:bodyPr wrap="square" lIns="0" tIns="0" rIns="0" bIns="0">
+          <a:bodyPr wrap="square">
             <a:spAutoFit/>
           </a:bodyPr>
           <a:lstStyle/>
@@ -4539,6 +4686,7 @@
                 <a:solidFill>
                   <a:srgbClr val="FFFFFF"/>
                 </a:solidFill>
+                <a:latin typeface="Arial"/>
               </a:defRPr>
             </a:pPr>
             <a:r>
@@ -4549,14 +4697,14 @@
       </p:sp>
       <p:sp>
         <p:nvSpPr>
-          <p:cNvPr id="5" name="Rounded Rectangle 4"/>
+          <p:cNvPr id="4" name="Rounded Rectangle 3"/>
           <p:cNvSpPr/>
           <p:nvPr/>
         </p:nvSpPr>
         <p:spPr>
           <a:xfrm>
-            <a:off x="731520" y="1463040"/>
-            <a:ext cx="3328416" cy="4846320"/>
+            <a:off x="731520" y="1417320"/>
+            <a:ext cx="3328416" cy="4937760"/>
           </a:xfrm>
           <a:prstGeom prst="roundRect">
             <a:avLst/>
@@ -4564,7 +4712,7 @@
           <a:solidFill>
             <a:srgbClr val="262030"/>
           </a:solidFill>
-          <a:ln>
+          <a:ln w="19050">
             <a:solidFill>
               <a:srgbClr val="413750"/>
             </a:solidFill>
@@ -4585,17 +4733,44 @@
           </a:fontRef>
         </p:style>
         <p:txBody>
-          <a:bodyPr rtlCol="0" anchor="ctr" wrap="square" lIns="274320" tIns="274320" rIns="274320" bIns="274320"/>
-          <a:lstStyle/>
-          <a:p>
-            <a:pPr algn="ctr">
-              <a:spcAft>
-                <a:spcPts val="1200"/>
+          <a:bodyPr rtlCol="0" anchor="ctr"/>
+          <a:lstStyle/>
+          <a:p>
+            <a:pPr algn="ctr"/>
+          </a:p>
+        </p:txBody>
+      </p:sp>
+      <p:sp>
+        <p:nvSpPr>
+          <p:cNvPr id="5" name="TextBox 4"/>
+          <p:cNvSpPr txBox="1"/>
+          <p:nvPr/>
+        </p:nvSpPr>
+        <p:spPr>
+          <a:xfrm>
+            <a:off x="914400" y="1554480"/>
+            <a:ext cx="2962656" cy="4663440"/>
+          </a:xfrm>
+          <a:prstGeom prst="rect">
+            <a:avLst/>
+          </a:prstGeom>
+          <a:noFill/>
+        </p:spPr>
+        <p:txBody>
+          <a:bodyPr wrap="square">
+            <a:spAutoFit/>
+          </a:bodyPr>
+          <a:lstStyle/>
+          <a:p>
+            <a:pPr>
+              <a:spcAft>
+                <a:spcPts val="1000"/>
               </a:spcAft>
               <a:defRPr sz="1300" b="1">
                 <a:solidFill>
                   <a:srgbClr val="FFA062"/>
                 </a:solidFill>
+                <a:latin typeface="Arial"/>
               </a:defRPr>
             </a:pPr>
             <a:r>
@@ -4608,6 +4783,7 @@
                 <a:solidFill>
                   <a:srgbClr val="FFFFFF"/>
                 </a:solidFill>
+                <a:latin typeface="Arial"/>
               </a:defRPr>
             </a:pPr>
             <a:r>
@@ -4617,12 +4793,13 @@
           <a:p>
             <a:pPr>
               <a:spcAft>
-                <a:spcPts val="800"/>
-              </a:spcAft>
-              <a:defRPr sz="1000">
+                <a:spcPts val="700"/>
+              </a:spcAft>
+              <a:defRPr sz="950">
                 <a:solidFill>
                   <a:srgbClr val="B9AFC6"/>
                 </a:solidFill>
+                <a:latin typeface="Arial"/>
               </a:defRPr>
             </a:pPr>
             <a:r>
@@ -4635,6 +4812,7 @@
                 <a:solidFill>
                   <a:srgbClr val="FFFFFF"/>
                 </a:solidFill>
+                <a:latin typeface="Arial"/>
               </a:defRPr>
             </a:pPr>
             <a:r>
@@ -4644,12 +4822,13 @@
           <a:p>
             <a:pPr>
               <a:spcAft>
-                <a:spcPts val="800"/>
-              </a:spcAft>
-              <a:defRPr sz="1000">
+                <a:spcPts val="700"/>
+              </a:spcAft>
+              <a:defRPr sz="950">
                 <a:solidFill>
                   <a:srgbClr val="B9AFC6"/>
                 </a:solidFill>
+                <a:latin typeface="Arial"/>
               </a:defRPr>
             </a:pPr>
             <a:r>
@@ -4662,6 +4841,7 @@
                 <a:solidFill>
                   <a:srgbClr val="FFFFFF"/>
                 </a:solidFill>
+                <a:latin typeface="Arial"/>
               </a:defRPr>
             </a:pPr>
             <a:r>
@@ -4671,12 +4851,13 @@
           <a:p>
             <a:pPr>
               <a:spcAft>
-                <a:spcPts val="800"/>
-              </a:spcAft>
-              <a:defRPr sz="1000">
+                <a:spcPts val="700"/>
+              </a:spcAft>
+              <a:defRPr sz="950">
                 <a:solidFill>
                   <a:srgbClr val="B9AFC6"/>
                 </a:solidFill>
+                <a:latin typeface="Arial"/>
               </a:defRPr>
             </a:pPr>
             <a:r>
@@ -4689,6 +4870,7 @@
                 <a:solidFill>
                   <a:srgbClr val="FFFFFF"/>
                 </a:solidFill>
+                <a:latin typeface="Arial"/>
               </a:defRPr>
             </a:pPr>
             <a:r>
@@ -4698,12 +4880,13 @@
           <a:p>
             <a:pPr>
               <a:spcAft>
-                <a:spcPts val="800"/>
-              </a:spcAft>
-              <a:defRPr sz="1000">
+                <a:spcPts val="700"/>
+              </a:spcAft>
+              <a:defRPr sz="950">
                 <a:solidFill>
                   <a:srgbClr val="B9AFC6"/>
                 </a:solidFill>
+                <a:latin typeface="Arial"/>
               </a:defRPr>
             </a:pPr>
             <a:r>
@@ -4720,8 +4903,8 @@
         </p:nvSpPr>
         <p:spPr>
           <a:xfrm>
-            <a:off x="4389120" y="1463040"/>
-            <a:ext cx="3328416" cy="4846320"/>
+            <a:off x="4389120" y="1417320"/>
+            <a:ext cx="3328416" cy="4937760"/>
           </a:xfrm>
           <a:prstGeom prst="roundRect">
             <a:avLst/>
@@ -4729,7 +4912,7 @@
           <a:solidFill>
             <a:srgbClr val="262030"/>
           </a:solidFill>
-          <a:ln>
+          <a:ln w="19050">
             <a:solidFill>
               <a:srgbClr val="413750"/>
             </a:solidFill>
@@ -4750,17 +4933,44 @@
           </a:fontRef>
         </p:style>
         <p:txBody>
-          <a:bodyPr rtlCol="0" anchor="ctr" wrap="square" lIns="274320" tIns="274320" rIns="274320" bIns="274320"/>
-          <a:lstStyle/>
-          <a:p>
-            <a:pPr algn="ctr">
-              <a:spcAft>
-                <a:spcPts val="1200"/>
+          <a:bodyPr rtlCol="0" anchor="ctr"/>
+          <a:lstStyle/>
+          <a:p>
+            <a:pPr algn="ctr"/>
+          </a:p>
+        </p:txBody>
+      </p:sp>
+      <p:sp>
+        <p:nvSpPr>
+          <p:cNvPr id="7" name="TextBox 6"/>
+          <p:cNvSpPr txBox="1"/>
+          <p:nvPr/>
+        </p:nvSpPr>
+        <p:spPr>
+          <a:xfrm>
+            <a:off x="4572000" y="1554480"/>
+            <a:ext cx="2962656" cy="4663440"/>
+          </a:xfrm>
+          <a:prstGeom prst="rect">
+            <a:avLst/>
+          </a:prstGeom>
+          <a:noFill/>
+        </p:spPr>
+        <p:txBody>
+          <a:bodyPr wrap="square">
+            <a:spAutoFit/>
+          </a:bodyPr>
+          <a:lstStyle/>
+          <a:p>
+            <a:pPr>
+              <a:spcAft>
+                <a:spcPts val="1000"/>
               </a:spcAft>
               <a:defRPr sz="1300" b="1">
                 <a:solidFill>
                   <a:srgbClr val="3B82F6"/>
                 </a:solidFill>
+                <a:latin typeface="Arial"/>
               </a:defRPr>
             </a:pPr>
             <a:r>
@@ -4773,21 +4983,23 @@
                 <a:solidFill>
                   <a:srgbClr val="FFFFFF"/>
                 </a:solidFill>
-              </a:defRPr>
-            </a:pPr>
-            <a:r>
-              <a:t>⚡ Stateless JWT Authentication</a:t>
-            </a:r>
-          </a:p>
-          <a:p>
-            <a:pPr>
-              <a:spcAft>
-                <a:spcPts val="800"/>
-              </a:spcAft>
-              <a:defRPr sz="1000">
+                <a:latin typeface="Arial"/>
+              </a:defRPr>
+            </a:pPr>
+            <a:r>
+              <a:t>⚡ Stateless JWT Auth</a:t>
+            </a:r>
+          </a:p>
+          <a:p>
+            <a:pPr>
+              <a:spcAft>
+                <a:spcPts val="700"/>
+              </a:spcAft>
+              <a:defRPr sz="950">
                 <a:solidFill>
                   <a:srgbClr val="B9AFC6"/>
                 </a:solidFill>
+                <a:latin typeface="Arial"/>
               </a:defRPr>
             </a:pPr>
             <a:r>
@@ -4800,6 +5012,7 @@
                 <a:solidFill>
                   <a:srgbClr val="FFFFFF"/>
                 </a:solidFill>
+                <a:latin typeface="Arial"/>
               </a:defRPr>
             </a:pPr>
             <a:r>
@@ -4809,12 +5022,13 @@
           <a:p>
             <a:pPr>
               <a:spcAft>
-                <a:spcPts val="800"/>
-              </a:spcAft>
-              <a:defRPr sz="1000">
+                <a:spcPts val="700"/>
+              </a:spcAft>
+              <a:defRPr sz="950">
                 <a:solidFill>
                   <a:srgbClr val="B9AFC6"/>
                 </a:solidFill>
+                <a:latin typeface="Arial"/>
               </a:defRPr>
             </a:pPr>
             <a:r>
@@ -4827,25 +5041,27 @@
                 <a:solidFill>
                   <a:srgbClr val="FFFFFF"/>
                 </a:solidFill>
-              </a:defRPr>
-            </a:pPr>
-            <a:r>
-              <a:t>⚡ Role-Based Access Control</a:t>
-            </a:r>
-          </a:p>
-          <a:p>
-            <a:pPr>
-              <a:spcAft>
-                <a:spcPts val="800"/>
-              </a:spcAft>
-              <a:defRPr sz="1000">
+                <a:latin typeface="Arial"/>
+              </a:defRPr>
+            </a:pPr>
+            <a:r>
+              <a:t>⚡ Strict Role Barrier (RBAC)</a:t>
+            </a:r>
+          </a:p>
+          <a:p>
+            <a:pPr>
+              <a:spcAft>
+                <a:spcPts val="700"/>
+              </a:spcAft>
+              <a:defRPr sz="950">
                 <a:solidFill>
                   <a:srgbClr val="B9AFC6"/>
                 </a:solidFill>
-              </a:defRPr>
-            </a:pPr>
-            <a:r>
-              <a:t>Strict barrier preventing retailers from listing stock and wholesalers from placing orders.</a:t>
+                <a:latin typeface="Arial"/>
+              </a:defRPr>
+            </a:pPr>
+            <a:r>
+              <a:t>Prevents retailers from listing stock and wholesalers from placing orders.</a:t>
             </a:r>
           </a:p>
           <a:p>
@@ -4854,6 +5070,7 @@
                 <a:solidFill>
                   <a:srgbClr val="FFFFFF"/>
                 </a:solidFill>
+                <a:latin typeface="Arial"/>
               </a:defRPr>
             </a:pPr>
             <a:r>
@@ -4863,12 +5080,13 @@
           <a:p>
             <a:pPr>
               <a:spcAft>
-                <a:spcPts val="800"/>
-              </a:spcAft>
-              <a:defRPr sz="1000">
+                <a:spcPts val="700"/>
+              </a:spcAft>
+              <a:defRPr sz="950">
                 <a:solidFill>
                   <a:srgbClr val="B9AFC6"/>
                 </a:solidFill>
+                <a:latin typeface="Arial"/>
               </a:defRPr>
             </a:pPr>
             <a:r>
@@ -4879,14 +5097,14 @@
       </p:sp>
       <p:sp>
         <p:nvSpPr>
-          <p:cNvPr id="7" name="Rounded Rectangle 6"/>
+          <p:cNvPr id="8" name="Rounded Rectangle 7"/>
           <p:cNvSpPr/>
           <p:nvPr/>
         </p:nvSpPr>
         <p:spPr>
           <a:xfrm>
-            <a:off x="8046720" y="1463040"/>
-            <a:ext cx="3328416" cy="4846320"/>
+            <a:off x="8046720" y="1417320"/>
+            <a:ext cx="3328416" cy="4937760"/>
           </a:xfrm>
           <a:prstGeom prst="roundRect">
             <a:avLst/>
@@ -4894,7 +5112,7 @@
           <a:solidFill>
             <a:srgbClr val="262030"/>
           </a:solidFill>
-          <a:ln>
+          <a:ln w="19050">
             <a:solidFill>
               <a:srgbClr val="413750"/>
             </a:solidFill>
@@ -4915,17 +5133,44 @@
           </a:fontRef>
         </p:style>
         <p:txBody>
-          <a:bodyPr rtlCol="0" anchor="ctr" wrap="square" lIns="274320" tIns="274320" rIns="274320" bIns="274320"/>
-          <a:lstStyle/>
-          <a:p>
-            <a:pPr algn="ctr">
-              <a:spcAft>
-                <a:spcPts val="1200"/>
+          <a:bodyPr rtlCol="0" anchor="ctr"/>
+          <a:lstStyle/>
+          <a:p>
+            <a:pPr algn="ctr"/>
+          </a:p>
+        </p:txBody>
+      </p:sp>
+      <p:sp>
+        <p:nvSpPr>
+          <p:cNvPr id="9" name="TextBox 8"/>
+          <p:cNvSpPr txBox="1"/>
+          <p:nvPr/>
+        </p:nvSpPr>
+        <p:spPr>
+          <a:xfrm>
+            <a:off x="8229600" y="1554480"/>
+            <a:ext cx="2962656" cy="4663440"/>
+          </a:xfrm>
+          <a:prstGeom prst="rect">
+            <a:avLst/>
+          </a:prstGeom>
+          <a:noFill/>
+        </p:spPr>
+        <p:txBody>
+          <a:bodyPr wrap="square">
+            <a:spAutoFit/>
+          </a:bodyPr>
+          <a:lstStyle/>
+          <a:p>
+            <a:pPr>
+              <a:spcAft>
+                <a:spcPts val="1000"/>
               </a:spcAft>
               <a:defRPr sz="1300" b="1">
                 <a:solidFill>
                   <a:srgbClr val="22C55E"/>
                 </a:solidFill>
+                <a:latin typeface="Arial"/>
               </a:defRPr>
             </a:pPr>
             <a:r>
@@ -4938,6 +5183,7 @@
                 <a:solidFill>
                   <a:srgbClr val="FFFFFF"/>
                 </a:solidFill>
+                <a:latin typeface="Arial"/>
               </a:defRPr>
             </a:pPr>
             <a:r>
@@ -4947,12 +5193,13 @@
           <a:p>
             <a:pPr>
               <a:spcAft>
-                <a:spcPts val="800"/>
-              </a:spcAft>
-              <a:defRPr sz="1000">
+                <a:spcPts val="700"/>
+              </a:spcAft>
+              <a:defRPr sz="950">
                 <a:solidFill>
                   <a:srgbClr val="B9AFC6"/>
                 </a:solidFill>
+                <a:latin typeface="Arial"/>
               </a:defRPr>
             </a:pPr>
             <a:r>
@@ -4965,6 +5212,7 @@
                 <a:solidFill>
                   <a:srgbClr val="FFFFFF"/>
                 </a:solidFill>
+                <a:latin typeface="Arial"/>
               </a:defRPr>
             </a:pPr>
             <a:r>
@@ -4974,12 +5222,13 @@
           <a:p>
             <a:pPr>
               <a:spcAft>
-                <a:spcPts val="800"/>
-              </a:spcAft>
-              <a:defRPr sz="1000">
+                <a:spcPts val="700"/>
+              </a:spcAft>
+              <a:defRPr sz="950">
                 <a:solidFill>
                   <a:srgbClr val="B9AFC6"/>
                 </a:solidFill>
+                <a:latin typeface="Arial"/>
               </a:defRPr>
             </a:pPr>
             <a:r>
@@ -4992,6 +5241,7 @@
                 <a:solidFill>
                   <a:srgbClr val="FFFFFF"/>
                 </a:solidFill>
+                <a:latin typeface="Arial"/>
               </a:defRPr>
             </a:pPr>
             <a:r>
@@ -5001,12 +5251,13 @@
           <a:p>
             <a:pPr>
               <a:spcAft>
-                <a:spcPts val="800"/>
-              </a:spcAft>
-              <a:defRPr sz="1000">
+                <a:spcPts val="700"/>
+              </a:spcAft>
+              <a:defRPr sz="950">
                 <a:solidFill>
                   <a:srgbClr val="B9AFC6"/>
                 </a:solidFill>
+                <a:latin typeface="Arial"/>
               </a:defRPr>
             </a:pPr>
             <a:r>
@@ -5019,6 +5270,7 @@
                 <a:solidFill>
                   <a:srgbClr val="FFFFFF"/>
                 </a:solidFill>
+                <a:latin typeface="Arial"/>
               </a:defRPr>
             </a:pPr>
             <a:r>
@@ -5028,12 +5280,13 @@
           <a:p>
             <a:pPr>
               <a:spcAft>
-                <a:spcPts val="800"/>
-              </a:spcAft>
-              <a:defRPr sz="1000">
+                <a:spcPts val="700"/>
+              </a:spcAft>
+              <a:defRPr sz="950">
                 <a:solidFill>
                   <a:srgbClr val="B9AFC6"/>
                 </a:solidFill>
+                <a:latin typeface="Arial"/>
               </a:defRPr>
             </a:pPr>
             <a:r>
@@ -5053,6 +5306,14 @@
 <file path=ppt/slides/slide4.xml><?xml version="1.0" encoding="utf-8"?>
 <p:sld xmlns:a="http://schemas.openxmlformats.org/drawingml/2006/main" xmlns:p="http://schemas.openxmlformats.org/presentationml/2006/main" xmlns:r="http://schemas.openxmlformats.org/officeDocument/2006/relationships">
   <p:cSld>
+    <p:bg>
+      <p:bgPr>
+        <a:solidFill>
+          <a:srgbClr val="1A1622"/>
+        </a:solidFill>
+        <a:effectLst/>
+      </p:bgPr>
+    </p:bg>
     <p:spTree>
       <p:nvGrpSpPr>
         <p:cNvPr id="1" name=""/>
@@ -5062,57 +5323,14 @@
       <p:grpSpPr/>
       <p:sp>
         <p:nvSpPr>
-          <p:cNvPr id="2" name="Rectangle 1"/>
-          <p:cNvSpPr/>
-          <p:nvPr/>
-        </p:nvSpPr>
-        <p:spPr>
-          <a:xfrm>
-            <a:off x="0" y="0"/>
-            <a:ext cx="12191695" cy="6858000"/>
-          </a:xfrm>
-          <a:prstGeom prst="rect">
-            <a:avLst/>
-          </a:prstGeom>
-          <a:solidFill>
-            <a:srgbClr val="1A1622"/>
-          </a:solidFill>
-          <a:ln>
-            <a:noFill/>
-          </a:ln>
-        </p:spPr>
-        <p:style>
-          <a:lnRef idx="1">
-            <a:schemeClr val="accent1"/>
-          </a:lnRef>
-          <a:fillRef idx="3">
-            <a:schemeClr val="accent1"/>
-          </a:fillRef>
-          <a:effectRef idx="2">
-            <a:schemeClr val="accent1"/>
-          </a:effectRef>
-          <a:fontRef idx="minor">
-            <a:schemeClr val="lt1"/>
-          </a:fontRef>
-        </p:style>
-        <p:txBody>
-          <a:bodyPr rtlCol="0" anchor="ctr"/>
-          <a:lstStyle/>
-          <a:p>
-            <a:pPr algn="ctr"/>
-          </a:p>
-        </p:txBody>
-      </p:sp>
-      <p:sp>
-        <p:nvSpPr>
-          <p:cNvPr id="3" name="TextBox 2"/>
+          <p:cNvPr id="2" name="TextBox 1"/>
           <p:cNvSpPr txBox="1"/>
           <p:nvPr/>
         </p:nvSpPr>
         <p:spPr>
           <a:xfrm>
             <a:off x="731520" y="365760"/>
-            <a:ext cx="10698480" cy="365760"/>
+            <a:ext cx="10698480" cy="320040"/>
           </a:xfrm>
           <a:prstGeom prst="rect">
             <a:avLst/>
@@ -5120,7 +5338,7 @@
           <a:noFill/>
         </p:spPr>
         <p:txBody>
-          <a:bodyPr wrap="square" lIns="0" tIns="0" rIns="0" bIns="0">
+          <a:bodyPr wrap="square">
             <a:spAutoFit/>
           </a:bodyPr>
           <a:lstStyle/>
@@ -5130,6 +5348,7 @@
                 <a:solidFill>
                   <a:srgbClr val="FFA062"/>
                 </a:solidFill>
+                <a:latin typeface="Arial"/>
               </a:defRPr>
             </a:pPr>
             <a:r>
@@ -5140,14 +5359,14 @@
       </p:sp>
       <p:sp>
         <p:nvSpPr>
-          <p:cNvPr id="4" name="TextBox 3"/>
+          <p:cNvPr id="3" name="TextBox 2"/>
           <p:cNvSpPr txBox="1"/>
           <p:nvPr/>
         </p:nvSpPr>
         <p:spPr>
           <a:xfrm>
             <a:off x="731520" y="685800"/>
-            <a:ext cx="10698480" cy="640080"/>
+            <a:ext cx="10698480" cy="594360"/>
           </a:xfrm>
           <a:prstGeom prst="rect">
             <a:avLst/>
@@ -5155,7 +5374,7 @@
           <a:noFill/>
         </p:spPr>
         <p:txBody>
-          <a:bodyPr wrap="square" lIns="0" tIns="0" rIns="0" bIns="0">
+          <a:bodyPr wrap="square">
             <a:spAutoFit/>
           </a:bodyPr>
           <a:lstStyle/>
@@ -5165,6 +5384,7 @@
                 <a:solidFill>
                   <a:srgbClr val="FFFFFF"/>
                 </a:solidFill>
+                <a:latin typeface="Arial"/>
               </a:defRPr>
             </a:pPr>
             <a:r>
@@ -5175,14 +5395,14 @@
       </p:sp>
       <p:sp>
         <p:nvSpPr>
-          <p:cNvPr id="5" name="Rounded Rectangle 4"/>
+          <p:cNvPr id="4" name="Rounded Rectangle 3"/>
           <p:cNvSpPr/>
           <p:nvPr/>
         </p:nvSpPr>
         <p:spPr>
           <a:xfrm>
-            <a:off x="731520" y="1463040"/>
-            <a:ext cx="3328416" cy="4846320"/>
+            <a:off x="731520" y="1417320"/>
+            <a:ext cx="3328416" cy="4937760"/>
           </a:xfrm>
           <a:prstGeom prst="roundRect">
             <a:avLst/>
@@ -5190,7 +5410,7 @@
           <a:solidFill>
             <a:srgbClr val="262030"/>
           </a:solidFill>
-          <a:ln>
+          <a:ln w="19050">
             <a:solidFill>
               <a:srgbClr val="413750"/>
             </a:solidFill>
@@ -5211,17 +5431,44 @@
           </a:fontRef>
         </p:style>
         <p:txBody>
-          <a:bodyPr rtlCol="0" anchor="ctr" wrap="square" lIns="274320" tIns="274320" rIns="274320" bIns="274320"/>
-          <a:lstStyle/>
-          <a:p>
-            <a:pPr algn="ctr">
-              <a:spcAft>
-                <a:spcPts val="1200"/>
+          <a:bodyPr rtlCol="0" anchor="ctr"/>
+          <a:lstStyle/>
+          <a:p>
+            <a:pPr algn="ctr"/>
+          </a:p>
+        </p:txBody>
+      </p:sp>
+      <p:sp>
+        <p:nvSpPr>
+          <p:cNvPr id="5" name="TextBox 4"/>
+          <p:cNvSpPr txBox="1"/>
+          <p:nvPr/>
+        </p:nvSpPr>
+        <p:spPr>
+          <a:xfrm>
+            <a:off x="914400" y="1554480"/>
+            <a:ext cx="2962656" cy="4663440"/>
+          </a:xfrm>
+          <a:prstGeom prst="rect">
+            <a:avLst/>
+          </a:prstGeom>
+          <a:noFill/>
+        </p:spPr>
+        <p:txBody>
+          <a:bodyPr wrap="square">
+            <a:spAutoFit/>
+          </a:bodyPr>
+          <a:lstStyle/>
+          <a:p>
+            <a:pPr>
+              <a:spcAft>
+                <a:spcPts val="1000"/>
               </a:spcAft>
               <a:defRPr sz="1300" b="1">
                 <a:solidFill>
                   <a:srgbClr val="22C55E"/>
                 </a:solidFill>
+                <a:latin typeface="Arial"/>
               </a:defRPr>
             </a:pPr>
             <a:r>
@@ -5234,21 +5481,23 @@
                 <a:solidFill>
                   <a:srgbClr val="FFFFFF"/>
                 </a:solidFill>
-              </a:defRPr>
-            </a:pPr>
-            <a:r>
-              <a:t>★ Disintermediation</a:t>
-            </a:r>
-          </a:p>
-          <a:p>
-            <a:pPr>
-              <a:spcAft>
-                <a:spcPts val="800"/>
-              </a:spcAft>
-              <a:defRPr sz="1000">
+                <a:latin typeface="Arial"/>
+              </a:defRPr>
+            </a:pPr>
+            <a:r>
+              <a:t>★ Direct Disintermediation</a:t>
+            </a:r>
+          </a:p>
+          <a:p>
+            <a:pPr>
+              <a:spcAft>
+                <a:spcPts val="700"/>
+              </a:spcAft>
+              <a:defRPr sz="950">
                 <a:solidFill>
                   <a:srgbClr val="B9AFC6"/>
                 </a:solidFill>
+                <a:latin typeface="Arial"/>
               </a:defRPr>
             </a:pPr>
             <a:r>
@@ -5261,6 +5510,7 @@
                 <a:solidFill>
                   <a:srgbClr val="FFFFFF"/>
                 </a:solidFill>
+                <a:latin typeface="Arial"/>
               </a:defRPr>
             </a:pPr>
             <a:r>
@@ -5270,12 +5520,13 @@
           <a:p>
             <a:pPr>
               <a:spcAft>
-                <a:spcPts val="800"/>
-              </a:spcAft>
-              <a:defRPr sz="1000">
+                <a:spcPts val="700"/>
+              </a:spcAft>
+              <a:defRPr sz="950">
                 <a:solidFill>
                   <a:srgbClr val="B9AFC6"/>
                 </a:solidFill>
+                <a:latin typeface="Arial"/>
               </a:defRPr>
             </a:pPr>
             <a:r>
@@ -5288,6 +5539,7 @@
                 <a:solidFill>
                   <a:srgbClr val="FFFFFF"/>
                 </a:solidFill>
+                <a:latin typeface="Arial"/>
               </a:defRPr>
             </a:pPr>
             <a:r>
@@ -5297,12 +5549,13 @@
           <a:p>
             <a:pPr>
               <a:spcAft>
-                <a:spcPts val="800"/>
-              </a:spcAft>
-              <a:defRPr sz="1000">
+                <a:spcPts val="700"/>
+              </a:spcAft>
+              <a:defRPr sz="950">
                 <a:solidFill>
                   <a:srgbClr val="B9AFC6"/>
                 </a:solidFill>
+                <a:latin typeface="Arial"/>
               </a:defRPr>
             </a:pPr>
             <a:r>
@@ -5315,6 +5568,7 @@
                 <a:solidFill>
                   <a:srgbClr val="FFFFFF"/>
                 </a:solidFill>
+                <a:latin typeface="Arial"/>
               </a:defRPr>
             </a:pPr>
             <a:r>
@@ -5324,12 +5578,13 @@
           <a:p>
             <a:pPr>
               <a:spcAft>
-                <a:spcPts val="800"/>
-              </a:spcAft>
-              <a:defRPr sz="1000">
+                <a:spcPts val="700"/>
+              </a:spcAft>
+              <a:defRPr sz="950">
                 <a:solidFill>
                   <a:srgbClr val="B9AFC6"/>
                 </a:solidFill>
+                <a:latin typeface="Arial"/>
               </a:defRPr>
             </a:pPr>
             <a:r>
@@ -5346,8 +5601,8 @@
         </p:nvSpPr>
         <p:spPr>
           <a:xfrm>
-            <a:off x="4389120" y="1463040"/>
-            <a:ext cx="3328416" cy="4846320"/>
+            <a:off x="4389120" y="1417320"/>
+            <a:ext cx="3328416" cy="4937760"/>
           </a:xfrm>
           <a:prstGeom prst="roundRect">
             <a:avLst/>
@@ -5355,7 +5610,7 @@
           <a:solidFill>
             <a:srgbClr val="262030"/>
           </a:solidFill>
-          <a:ln>
+          <a:ln w="19050">
             <a:solidFill>
               <a:srgbClr val="413750"/>
             </a:solidFill>
@@ -5376,17 +5631,44 @@
           </a:fontRef>
         </p:style>
         <p:txBody>
-          <a:bodyPr rtlCol="0" anchor="ctr" wrap="square" lIns="274320" tIns="274320" rIns="274320" bIns="274320"/>
-          <a:lstStyle/>
-          <a:p>
-            <a:pPr algn="ctr">
-              <a:spcAft>
-                <a:spcPts val="1200"/>
+          <a:bodyPr rtlCol="0" anchor="ctr"/>
+          <a:lstStyle/>
+          <a:p>
+            <a:pPr algn="ctr"/>
+          </a:p>
+        </p:txBody>
+      </p:sp>
+      <p:sp>
+        <p:nvSpPr>
+          <p:cNvPr id="7" name="TextBox 6"/>
+          <p:cNvSpPr txBox="1"/>
+          <p:nvPr/>
+        </p:nvSpPr>
+        <p:spPr>
+          <a:xfrm>
+            <a:off x="4572000" y="1554480"/>
+            <a:ext cx="2962656" cy="4663440"/>
+          </a:xfrm>
+          <a:prstGeom prst="rect">
+            <a:avLst/>
+          </a:prstGeom>
+          <a:noFill/>
+        </p:spPr>
+        <p:txBody>
+          <a:bodyPr wrap="square">
+            <a:spAutoFit/>
+          </a:bodyPr>
+          <a:lstStyle/>
+          <a:p>
+            <a:pPr>
+              <a:spcAft>
+                <a:spcPts val="1000"/>
               </a:spcAft>
               <a:defRPr sz="1300" b="1">
                 <a:solidFill>
                   <a:srgbClr val="FFA062"/>
                 </a:solidFill>
+                <a:latin typeface="Arial"/>
               </a:defRPr>
             </a:pPr>
             <a:r>
@@ -5399,6 +5681,7 @@
                 <a:solidFill>
                   <a:srgbClr val="FFFFFF"/>
                 </a:solidFill>
+                <a:latin typeface="Arial"/>
               </a:defRPr>
             </a:pPr>
             <a:r>
@@ -5408,12 +5691,13 @@
           <a:p>
             <a:pPr>
               <a:spcAft>
-                <a:spcPts val="800"/>
-              </a:spcAft>
-              <a:defRPr sz="1000">
+                <a:spcPts val="700"/>
+              </a:spcAft>
+              <a:defRPr sz="950">
                 <a:solidFill>
                   <a:srgbClr val="B9AFC6"/>
                 </a:solidFill>
+                <a:latin typeface="Arial"/>
               </a:defRPr>
             </a:pPr>
             <a:r>
@@ -5426,6 +5710,7 @@
                 <a:solidFill>
                   <a:srgbClr val="FFFFFF"/>
                 </a:solidFill>
+                <a:latin typeface="Arial"/>
               </a:defRPr>
             </a:pPr>
             <a:r>
@@ -5435,12 +5720,13 @@
           <a:p>
             <a:pPr>
               <a:spcAft>
-                <a:spcPts val="800"/>
-              </a:spcAft>
-              <a:defRPr sz="1000">
+                <a:spcPts val="700"/>
+              </a:spcAft>
+              <a:defRPr sz="950">
                 <a:solidFill>
                   <a:srgbClr val="B9AFC6"/>
                 </a:solidFill>
+                <a:latin typeface="Arial"/>
               </a:defRPr>
             </a:pPr>
             <a:r>
@@ -5453,6 +5739,7 @@
                 <a:solidFill>
                   <a:srgbClr val="FFFFFF"/>
                 </a:solidFill>
+                <a:latin typeface="Arial"/>
               </a:defRPr>
             </a:pPr>
             <a:r>
@@ -5462,12 +5749,13 @@
           <a:p>
             <a:pPr>
               <a:spcAft>
-                <a:spcPts val="800"/>
-              </a:spcAft>
-              <a:defRPr sz="1000">
+                <a:spcPts val="700"/>
+              </a:spcAft>
+              <a:defRPr sz="950">
                 <a:solidFill>
                   <a:srgbClr val="B9AFC6"/>
                 </a:solidFill>
+                <a:latin typeface="Arial"/>
               </a:defRPr>
             </a:pPr>
             <a:r>
@@ -5480,6 +5768,7 @@
                 <a:solidFill>
                   <a:srgbClr val="FFFFFF"/>
                 </a:solidFill>
+                <a:latin typeface="Arial"/>
               </a:defRPr>
             </a:pPr>
             <a:r>
@@ -5489,12 +5778,13 @@
           <a:p>
             <a:pPr>
               <a:spcAft>
-                <a:spcPts val="800"/>
-              </a:spcAft>
-              <a:defRPr sz="1000">
+                <a:spcPts val="700"/>
+              </a:spcAft>
+              <a:defRPr sz="950">
                 <a:solidFill>
                   <a:srgbClr val="B9AFC6"/>
                 </a:solidFill>
+                <a:latin typeface="Arial"/>
               </a:defRPr>
             </a:pPr>
             <a:r>
@@ -5505,14 +5795,14 @@
       </p:sp>
       <p:sp>
         <p:nvSpPr>
-          <p:cNvPr id="7" name="Rounded Rectangle 6"/>
+          <p:cNvPr id="8" name="Rounded Rectangle 7"/>
           <p:cNvSpPr/>
           <p:nvPr/>
         </p:nvSpPr>
         <p:spPr>
           <a:xfrm>
-            <a:off x="8046720" y="1463040"/>
-            <a:ext cx="3328416" cy="4846320"/>
+            <a:off x="8046720" y="1417320"/>
+            <a:ext cx="3328416" cy="4937760"/>
           </a:xfrm>
           <a:prstGeom prst="roundRect">
             <a:avLst/>
@@ -5520,7 +5810,7 @@
           <a:solidFill>
             <a:srgbClr val="262030"/>
           </a:solidFill>
-          <a:ln>
+          <a:ln w="19050">
             <a:solidFill>
               <a:srgbClr val="413750"/>
             </a:solidFill>
@@ -5541,17 +5831,44 @@
           </a:fontRef>
         </p:style>
         <p:txBody>
-          <a:bodyPr rtlCol="0" anchor="ctr" wrap="square" lIns="274320" tIns="274320" rIns="274320" bIns="274320"/>
-          <a:lstStyle/>
-          <a:p>
-            <a:pPr algn="ctr">
-              <a:spcAft>
-                <a:spcPts val="1200"/>
+          <a:bodyPr rtlCol="0" anchor="ctr"/>
+          <a:lstStyle/>
+          <a:p>
+            <a:pPr algn="ctr"/>
+          </a:p>
+        </p:txBody>
+      </p:sp>
+      <p:sp>
+        <p:nvSpPr>
+          <p:cNvPr id="9" name="TextBox 8"/>
+          <p:cNvSpPr txBox="1"/>
+          <p:nvPr/>
+        </p:nvSpPr>
+        <p:spPr>
+          <a:xfrm>
+            <a:off x="8229600" y="1554480"/>
+            <a:ext cx="2962656" cy="4663440"/>
+          </a:xfrm>
+          <a:prstGeom prst="rect">
+            <a:avLst/>
+          </a:prstGeom>
+          <a:noFill/>
+        </p:spPr>
+        <p:txBody>
+          <a:bodyPr wrap="square">
+            <a:spAutoFit/>
+          </a:bodyPr>
+          <a:lstStyle/>
+          <a:p>
+            <a:pPr>
+              <a:spcAft>
+                <a:spcPts val="1000"/>
               </a:spcAft>
               <a:defRPr sz="1300" b="1">
                 <a:solidFill>
                   <a:srgbClr val="3B82F6"/>
                 </a:solidFill>
+                <a:latin typeface="Arial"/>
               </a:defRPr>
             </a:pPr>
             <a:r>
@@ -5564,6 +5881,7 @@
                 <a:solidFill>
                   <a:srgbClr val="FFFFFF"/>
                 </a:solidFill>
+                <a:latin typeface="Arial"/>
               </a:defRPr>
             </a:pPr>
             <a:r>
@@ -5573,12 +5891,13 @@
           <a:p>
             <a:pPr>
               <a:spcAft>
-                <a:spcPts val="800"/>
-              </a:spcAft>
-              <a:defRPr sz="1000">
+                <a:spcPts val="700"/>
+              </a:spcAft>
+              <a:defRPr sz="950">
                 <a:solidFill>
                   <a:srgbClr val="B9AFC6"/>
                 </a:solidFill>
+                <a:latin typeface="Arial"/>
               </a:defRPr>
             </a:pPr>
             <a:r>
@@ -5591,6 +5910,7 @@
                 <a:solidFill>
                   <a:srgbClr val="FFFFFF"/>
                 </a:solidFill>
+                <a:latin typeface="Arial"/>
               </a:defRPr>
             </a:pPr>
             <a:r>
@@ -5600,12 +5920,13 @@
           <a:p>
             <a:pPr>
               <a:spcAft>
-                <a:spcPts val="800"/>
-              </a:spcAft>
-              <a:defRPr sz="1000">
+                <a:spcPts val="700"/>
+              </a:spcAft>
+              <a:defRPr sz="950">
                 <a:solidFill>
                   <a:srgbClr val="B9AFC6"/>
                 </a:solidFill>
+                <a:latin typeface="Arial"/>
               </a:defRPr>
             </a:pPr>
             <a:r>
@@ -5618,6 +5939,7 @@
                 <a:solidFill>
                   <a:srgbClr val="FFFFFF"/>
                 </a:solidFill>
+                <a:latin typeface="Arial"/>
               </a:defRPr>
             </a:pPr>
             <a:r>
@@ -5627,12 +5949,13 @@
           <a:p>
             <a:pPr>
               <a:spcAft>
-                <a:spcPts val="800"/>
-              </a:spcAft>
-              <a:defRPr sz="1000">
+                <a:spcPts val="700"/>
+              </a:spcAft>
+              <a:defRPr sz="950">
                 <a:solidFill>
                   <a:srgbClr val="B9AFC6"/>
                 </a:solidFill>
+                <a:latin typeface="Arial"/>
               </a:defRPr>
             </a:pPr>
             <a:r>
@@ -5645,6 +5968,7 @@
                 <a:solidFill>
                   <a:srgbClr val="FFFFFF"/>
                 </a:solidFill>
+                <a:latin typeface="Arial"/>
               </a:defRPr>
             </a:pPr>
             <a:r>
@@ -5654,12 +5978,13 @@
           <a:p>
             <a:pPr>
               <a:spcAft>
-                <a:spcPts val="800"/>
-              </a:spcAft>
-              <a:defRPr sz="1000">
+                <a:spcPts val="700"/>
+              </a:spcAft>
+              <a:defRPr sz="950">
                 <a:solidFill>
                   <a:srgbClr val="B9AFC6"/>
                 </a:solidFill>
+                <a:latin typeface="Arial"/>
               </a:defRPr>
             </a:pPr>
             <a:r>
@@ -5679,6 +6004,14 @@
 <file path=ppt/slides/slide5.xml><?xml version="1.0" encoding="utf-8"?>
 <p:sld xmlns:a="http://schemas.openxmlformats.org/drawingml/2006/main" xmlns:p="http://schemas.openxmlformats.org/presentationml/2006/main" xmlns:r="http://schemas.openxmlformats.org/officeDocument/2006/relationships">
   <p:cSld>
+    <p:bg>
+      <p:bgPr>
+        <a:solidFill>
+          <a:srgbClr val="1A1622"/>
+        </a:solidFill>
+        <a:effectLst/>
+      </p:bgPr>
+    </p:bg>
     <p:spTree>
       <p:nvGrpSpPr>
         <p:cNvPr id="1" name=""/>
@@ -5688,57 +6021,14 @@
       <p:grpSpPr/>
       <p:sp>
         <p:nvSpPr>
-          <p:cNvPr id="2" name="Rectangle 1"/>
-          <p:cNvSpPr/>
-          <p:nvPr/>
-        </p:nvSpPr>
-        <p:spPr>
-          <a:xfrm>
-            <a:off x="0" y="0"/>
-            <a:ext cx="12191695" cy="6858000"/>
-          </a:xfrm>
-          <a:prstGeom prst="rect">
-            <a:avLst/>
-          </a:prstGeom>
-          <a:solidFill>
-            <a:srgbClr val="1A1622"/>
-          </a:solidFill>
-          <a:ln>
-            <a:noFill/>
-          </a:ln>
-        </p:spPr>
-        <p:style>
-          <a:lnRef idx="1">
-            <a:schemeClr val="accent1"/>
-          </a:lnRef>
-          <a:fillRef idx="3">
-            <a:schemeClr val="accent1"/>
-          </a:fillRef>
-          <a:effectRef idx="2">
-            <a:schemeClr val="accent1"/>
-          </a:effectRef>
-          <a:fontRef idx="minor">
-            <a:schemeClr val="lt1"/>
-          </a:fontRef>
-        </p:style>
-        <p:txBody>
-          <a:bodyPr rtlCol="0" anchor="ctr"/>
-          <a:lstStyle/>
-          <a:p>
-            <a:pPr algn="ctr"/>
-          </a:p>
-        </p:txBody>
-      </p:sp>
-      <p:sp>
-        <p:nvSpPr>
-          <p:cNvPr id="3" name="TextBox 2"/>
+          <p:cNvPr id="2" name="TextBox 1"/>
           <p:cNvSpPr txBox="1"/>
           <p:nvPr/>
         </p:nvSpPr>
         <p:spPr>
           <a:xfrm>
             <a:off x="731520" y="365760"/>
-            <a:ext cx="10698480" cy="365760"/>
+            <a:ext cx="10698480" cy="320040"/>
           </a:xfrm>
           <a:prstGeom prst="rect">
             <a:avLst/>
@@ -5746,7 +6036,7 @@
           <a:noFill/>
         </p:spPr>
         <p:txBody>
-          <a:bodyPr wrap="square" lIns="0" tIns="0" rIns="0" bIns="0">
+          <a:bodyPr wrap="square">
             <a:spAutoFit/>
           </a:bodyPr>
           <a:lstStyle/>
@@ -5756,6 +6046,7 @@
                 <a:solidFill>
                   <a:srgbClr val="FFA062"/>
                 </a:solidFill>
+                <a:latin typeface="Arial"/>
               </a:defRPr>
             </a:pPr>
             <a:r>
@@ -5766,14 +6057,14 @@
       </p:sp>
       <p:sp>
         <p:nvSpPr>
-          <p:cNvPr id="4" name="TextBox 3"/>
+          <p:cNvPr id="3" name="TextBox 2"/>
           <p:cNvSpPr txBox="1"/>
           <p:nvPr/>
         </p:nvSpPr>
         <p:spPr>
           <a:xfrm>
             <a:off x="731520" y="685800"/>
-            <a:ext cx="10698480" cy="640080"/>
+            <a:ext cx="10698480" cy="594360"/>
           </a:xfrm>
           <a:prstGeom prst="rect">
             <a:avLst/>
@@ -5781,7 +6072,7 @@
           <a:noFill/>
         </p:spPr>
         <p:txBody>
-          <a:bodyPr wrap="square" lIns="0" tIns="0" rIns="0" bIns="0">
+          <a:bodyPr wrap="square">
             <a:spAutoFit/>
           </a:bodyPr>
           <a:lstStyle/>
@@ -5791,6 +6082,7 @@
                 <a:solidFill>
                   <a:srgbClr val="FFFFFF"/>
                 </a:solidFill>
+                <a:latin typeface="Arial"/>
               </a:defRPr>
             </a:pPr>
             <a:r>
@@ -5801,14 +6093,14 @@
       </p:sp>
       <p:sp>
         <p:nvSpPr>
-          <p:cNvPr id="5" name="Rounded Rectangle 4"/>
+          <p:cNvPr id="4" name="Rounded Rectangle 3"/>
           <p:cNvSpPr/>
           <p:nvPr/>
         </p:nvSpPr>
         <p:spPr>
           <a:xfrm>
-            <a:off x="731520" y="1463040"/>
-            <a:ext cx="5120640" cy="4846320"/>
+            <a:off x="731520" y="1417320"/>
+            <a:ext cx="5120640" cy="4937760"/>
           </a:xfrm>
           <a:prstGeom prst="roundRect">
             <a:avLst/>
@@ -5816,7 +6108,7 @@
           <a:solidFill>
             <a:srgbClr val="262030"/>
           </a:solidFill>
-          <a:ln>
+          <a:ln w="19050">
             <a:solidFill>
               <a:srgbClr val="413750"/>
             </a:solidFill>
@@ -5837,17 +6129,44 @@
           </a:fontRef>
         </p:style>
         <p:txBody>
-          <a:bodyPr rtlCol="0" anchor="ctr" wrap="square" lIns="274320" tIns="274320" rIns="274320" bIns="274320"/>
-          <a:lstStyle/>
-          <a:p>
-            <a:pPr algn="ctr">
-              <a:spcAft>
-                <a:spcPts val="1200"/>
+          <a:bodyPr rtlCol="0" anchor="ctr"/>
+          <a:lstStyle/>
+          <a:p>
+            <a:pPr algn="ctr"/>
+          </a:p>
+        </p:txBody>
+      </p:sp>
+      <p:sp>
+        <p:nvSpPr>
+          <p:cNvPr id="5" name="TextBox 4"/>
+          <p:cNvSpPr txBox="1"/>
+          <p:nvPr/>
+        </p:nvSpPr>
+        <p:spPr>
+          <a:xfrm>
+            <a:off x="960120" y="1554480"/>
+            <a:ext cx="4663440" cy="4663440"/>
+          </a:xfrm>
+          <a:prstGeom prst="rect">
+            <a:avLst/>
+          </a:prstGeom>
+          <a:noFill/>
+        </p:spPr>
+        <p:txBody>
+          <a:bodyPr wrap="square">
+            <a:spAutoFit/>
+          </a:bodyPr>
+          <a:lstStyle/>
+          <a:p>
+            <a:pPr>
+              <a:spcAft>
+                <a:spcPts val="1000"/>
               </a:spcAft>
               <a:defRPr sz="1300" b="1">
                 <a:solidFill>
                   <a:srgbClr val="22C55E"/>
                 </a:solidFill>
+                <a:latin typeface="Arial"/>
               </a:defRPr>
             </a:pPr>
             <a:r>
@@ -5860,6 +6179,7 @@
                 <a:solidFill>
                   <a:srgbClr val="FFFFFF"/>
                 </a:solidFill>
+                <a:latin typeface="Arial"/>
               </a:defRPr>
             </a:pPr>
             <a:r>
@@ -5872,6 +6192,7 @@
                 <a:solidFill>
                   <a:srgbClr val="FFA062"/>
                 </a:solidFill>
+                <a:latin typeface="Arial"/>
               </a:defRPr>
             </a:pPr>
             <a:r>
@@ -5881,12 +6202,13 @@
           <a:p>
             <a:pPr>
               <a:spcAft>
-                <a:spcPts val="800"/>
+                <a:spcPts val="700"/>
               </a:spcAft>
               <a:defRPr sz="900">
                 <a:solidFill>
                   <a:srgbClr val="B9AFC6"/>
                 </a:solidFill>
+                <a:latin typeface="Arial"/>
               </a:defRPr>
             </a:pPr>
             <a:r>
@@ -5899,6 +6221,7 @@
                 <a:solidFill>
                   <a:srgbClr val="FFFFFF"/>
                 </a:solidFill>
+                <a:latin typeface="Arial"/>
               </a:defRPr>
             </a:pPr>
             <a:r>
@@ -5911,6 +6234,7 @@
                 <a:solidFill>
                   <a:srgbClr val="FFA062"/>
                 </a:solidFill>
+                <a:latin typeface="Arial"/>
               </a:defRPr>
             </a:pPr>
             <a:r>
@@ -5920,12 +6244,13 @@
           <a:p>
             <a:pPr>
               <a:spcAft>
-                <a:spcPts val="800"/>
+                <a:spcPts val="700"/>
               </a:spcAft>
               <a:defRPr sz="900">
                 <a:solidFill>
                   <a:srgbClr val="B9AFC6"/>
                 </a:solidFill>
+                <a:latin typeface="Arial"/>
               </a:defRPr>
             </a:pPr>
             <a:r>
@@ -5938,6 +6263,7 @@
                 <a:solidFill>
                   <a:srgbClr val="FFFFFF"/>
                 </a:solidFill>
+                <a:latin typeface="Arial"/>
               </a:defRPr>
             </a:pPr>
             <a:r>
@@ -5950,6 +6276,7 @@
                 <a:solidFill>
                   <a:srgbClr val="FFA062"/>
                 </a:solidFill>
+                <a:latin typeface="Arial"/>
               </a:defRPr>
             </a:pPr>
             <a:r>
@@ -5959,12 +6286,13 @@
           <a:p>
             <a:pPr>
               <a:spcAft>
-                <a:spcPts val="800"/>
+                <a:spcPts val="700"/>
               </a:spcAft>
               <a:defRPr sz="900">
                 <a:solidFill>
                   <a:srgbClr val="B9AFC6"/>
                 </a:solidFill>
+                <a:latin typeface="Arial"/>
               </a:defRPr>
             </a:pPr>
             <a:r>
@@ -5977,6 +6305,7 @@
                 <a:solidFill>
                   <a:srgbClr val="FFFFFF"/>
                 </a:solidFill>
+                <a:latin typeface="Arial"/>
               </a:defRPr>
             </a:pPr>
             <a:r>
@@ -5989,6 +6318,7 @@
                 <a:solidFill>
                   <a:srgbClr val="FFA062"/>
                 </a:solidFill>
+                <a:latin typeface="Arial"/>
               </a:defRPr>
             </a:pPr>
             <a:r>
@@ -5998,12 +6328,13 @@
           <a:p>
             <a:pPr>
               <a:spcAft>
-                <a:spcPts val="800"/>
+                <a:spcPts val="700"/>
               </a:spcAft>
               <a:defRPr sz="900">
                 <a:solidFill>
                   <a:srgbClr val="B9AFC6"/>
                 </a:solidFill>
+                <a:latin typeface="Arial"/>
               </a:defRPr>
             </a:pPr>
             <a:r>
@@ -6020,8 +6351,8 @@
         </p:nvSpPr>
         <p:spPr>
           <a:xfrm>
-            <a:off x="6217920" y="1463040"/>
-            <a:ext cx="5212080" cy="4846320"/>
+            <a:off x="6217920" y="1417320"/>
+            <a:ext cx="5212080" cy="4937760"/>
           </a:xfrm>
           <a:prstGeom prst="roundRect">
             <a:avLst/>
@@ -6029,7 +6360,7 @@
           <a:solidFill>
             <a:srgbClr val="262030"/>
           </a:solidFill>
-          <a:ln>
+          <a:ln w="19050">
             <a:solidFill>
               <a:srgbClr val="413750"/>
             </a:solidFill>
@@ -6050,17 +6381,44 @@
           </a:fontRef>
         </p:style>
         <p:txBody>
-          <a:bodyPr rtlCol="0" anchor="ctr" wrap="square" lIns="274320" tIns="274320" rIns="274320" bIns="274320"/>
-          <a:lstStyle/>
-          <a:p>
-            <a:pPr algn="ctr">
-              <a:spcAft>
-                <a:spcPts val="1200"/>
+          <a:bodyPr rtlCol="0" anchor="ctr"/>
+          <a:lstStyle/>
+          <a:p>
+            <a:pPr algn="ctr"/>
+          </a:p>
+        </p:txBody>
+      </p:sp>
+      <p:sp>
+        <p:nvSpPr>
+          <p:cNvPr id="7" name="TextBox 6"/>
+          <p:cNvSpPr txBox="1"/>
+          <p:nvPr/>
+        </p:nvSpPr>
+        <p:spPr>
+          <a:xfrm>
+            <a:off x="6446520" y="1554480"/>
+            <a:ext cx="4754880" cy="4663440"/>
+          </a:xfrm>
+          <a:prstGeom prst="rect">
+            <a:avLst/>
+          </a:prstGeom>
+          <a:noFill/>
+        </p:spPr>
+        <p:txBody>
+          <a:bodyPr wrap="square">
+            <a:spAutoFit/>
+          </a:bodyPr>
+          <a:lstStyle/>
+          <a:p>
+            <a:pPr>
+              <a:spcAft>
+                <a:spcPts val="1000"/>
               </a:spcAft>
               <a:defRPr sz="1300" b="1">
                 <a:solidFill>
                   <a:srgbClr val="FFA062"/>
                 </a:solidFill>
+                <a:latin typeface="Arial"/>
               </a:defRPr>
             </a:pPr>
             <a:r>
@@ -6073,6 +6431,7 @@
                 <a:solidFill>
                   <a:srgbClr val="FFFFFF"/>
                 </a:solidFill>
+                <a:latin typeface="Arial"/>
               </a:defRPr>
             </a:pPr>
             <a:r>
@@ -6082,12 +6441,13 @@
           <a:p>
             <a:pPr>
               <a:spcAft>
-                <a:spcPts val="600"/>
+                <a:spcPts val="500"/>
               </a:spcAft>
               <a:defRPr sz="950">
                 <a:solidFill>
-                  <a:srgbClr val="D7D0E1"/>
-                </a:solidFill>
+                  <a:srgbClr val="E1DAEB"/>
+                </a:solidFill>
+                <a:latin typeface="Arial"/>
               </a:defRPr>
             </a:pPr>
             <a:r>
@@ -6100,6 +6460,7 @@
                 <a:solidFill>
                   <a:srgbClr val="FFFFFF"/>
                 </a:solidFill>
+                <a:latin typeface="Arial"/>
               </a:defRPr>
             </a:pPr>
             <a:r>
@@ -6109,12 +6470,13 @@
           <a:p>
             <a:pPr>
               <a:spcAft>
-                <a:spcPts val="600"/>
+                <a:spcPts val="500"/>
               </a:spcAft>
               <a:defRPr sz="950">
                 <a:solidFill>
-                  <a:srgbClr val="D7D0E1"/>
-                </a:solidFill>
+                  <a:srgbClr val="E1DAEB"/>
+                </a:solidFill>
+                <a:latin typeface="Arial"/>
               </a:defRPr>
             </a:pPr>
             <a:r>
@@ -6127,6 +6489,7 @@
                 <a:solidFill>
                   <a:srgbClr val="FFFFFF"/>
                 </a:solidFill>
+                <a:latin typeface="Arial"/>
               </a:defRPr>
             </a:pPr>
             <a:r>
@@ -6136,12 +6499,13 @@
           <a:p>
             <a:pPr>
               <a:spcAft>
-                <a:spcPts val="600"/>
+                <a:spcPts val="500"/>
               </a:spcAft>
               <a:defRPr sz="950">
                 <a:solidFill>
-                  <a:srgbClr val="D7D0E1"/>
-                </a:solidFill>
+                  <a:srgbClr val="E1DAEB"/>
+                </a:solidFill>
+                <a:latin typeface="Arial"/>
               </a:defRPr>
             </a:pPr>
             <a:r>
@@ -6154,6 +6518,7 @@
                 <a:solidFill>
                   <a:srgbClr val="FFFFFF"/>
                 </a:solidFill>
+                <a:latin typeface="Arial"/>
               </a:defRPr>
             </a:pPr>
             <a:r>
@@ -6163,12 +6528,13 @@
           <a:p>
             <a:pPr>
               <a:spcAft>
-                <a:spcPts val="600"/>
+                <a:spcPts val="500"/>
               </a:spcAft>
               <a:defRPr sz="950">
                 <a:solidFill>
-                  <a:srgbClr val="D7D0E1"/>
-                </a:solidFill>
+                  <a:srgbClr val="E1DAEB"/>
+                </a:solidFill>
+                <a:latin typeface="Arial"/>
               </a:defRPr>
             </a:pPr>
             <a:r>
@@ -6181,6 +6547,7 @@
                 <a:solidFill>
                   <a:srgbClr val="FFFFFF"/>
                 </a:solidFill>
+                <a:latin typeface="Arial"/>
               </a:defRPr>
             </a:pPr>
             <a:r>
@@ -6190,12 +6557,13 @@
           <a:p>
             <a:pPr>
               <a:spcAft>
-                <a:spcPts val="600"/>
+                <a:spcPts val="500"/>
               </a:spcAft>
               <a:defRPr sz="950">
                 <a:solidFill>
-                  <a:srgbClr val="D7D0E1"/>
-                </a:solidFill>
+                  <a:srgbClr val="E1DAEB"/>
+                </a:solidFill>
+                <a:latin typeface="Arial"/>
               </a:defRPr>
             </a:pPr>
             <a:r>

</xml_diff>